<commit_message>
[feat] material 수정 및 animation 수정 불가
</commit_message>
<xml_diff>
--- a/바이너리화 한 파일 정보.pptx
+++ b/바이너리화 한 파일 정보.pptx
@@ -12,6 +12,8 @@
     <p:sldId id="260" r:id="rId6"/>
     <p:sldId id="262" r:id="rId7"/>
     <p:sldId id="261" r:id="rId8"/>
+    <p:sldId id="263" r:id="rId9"/>
+    <p:sldId id="264" r:id="rId10"/>
   </p:sldIdLst>
   <p:sldSz cx="12192000" cy="6858000"/>
   <p:notesSz cx="6858000" cy="9144000"/>
@@ -110,6 +112,11 @@
       </a:defRPr>
     </a:lvl9pPr>
   </p:defaultTextStyle>
+  <p:extLst>
+    <p:ext uri="{EFAFB233-063F-42B5-8137-9DF3F51BA10A}">
+      <p15:sldGuideLst xmlns:p15="http://schemas.microsoft.com/office/powerpoint/2012/main"/>
+    </p:ext>
+  </p:extLst>
 </p:presentation>
 </file>
 
@@ -260,7 +267,7 @@
           <a:p>
             <a:fld id="{48B2E156-3D9B-46D1-8B16-923D6BE61352}" type="datetimeFigureOut">
               <a:rPr lang="ko-KR" altLang="en-US" smtClean="0"/>
-              <a:t>2026-04-28</a:t>
+              <a:t>2026-05-08</a:t>
             </a:fld>
             <a:endParaRPr lang="ko-KR" altLang="en-US"/>
           </a:p>
@@ -458,7 +465,7 @@
           <a:p>
             <a:fld id="{48B2E156-3D9B-46D1-8B16-923D6BE61352}" type="datetimeFigureOut">
               <a:rPr lang="ko-KR" altLang="en-US" smtClean="0"/>
-              <a:t>2026-04-28</a:t>
+              <a:t>2026-05-08</a:t>
             </a:fld>
             <a:endParaRPr lang="ko-KR" altLang="en-US"/>
           </a:p>
@@ -666,7 +673,7 @@
           <a:p>
             <a:fld id="{48B2E156-3D9B-46D1-8B16-923D6BE61352}" type="datetimeFigureOut">
               <a:rPr lang="ko-KR" altLang="en-US" smtClean="0"/>
-              <a:t>2026-04-28</a:t>
+              <a:t>2026-05-08</a:t>
             </a:fld>
             <a:endParaRPr lang="ko-KR" altLang="en-US"/>
           </a:p>
@@ -864,7 +871,7 @@
           <a:p>
             <a:fld id="{48B2E156-3D9B-46D1-8B16-923D6BE61352}" type="datetimeFigureOut">
               <a:rPr lang="ko-KR" altLang="en-US" smtClean="0"/>
-              <a:t>2026-04-28</a:t>
+              <a:t>2026-05-08</a:t>
             </a:fld>
             <a:endParaRPr lang="ko-KR" altLang="en-US"/>
           </a:p>
@@ -1139,7 +1146,7 @@
           <a:p>
             <a:fld id="{48B2E156-3D9B-46D1-8B16-923D6BE61352}" type="datetimeFigureOut">
               <a:rPr lang="ko-KR" altLang="en-US" smtClean="0"/>
-              <a:t>2026-04-28</a:t>
+              <a:t>2026-05-08</a:t>
             </a:fld>
             <a:endParaRPr lang="ko-KR" altLang="en-US"/>
           </a:p>
@@ -1404,7 +1411,7 @@
           <a:p>
             <a:fld id="{48B2E156-3D9B-46D1-8B16-923D6BE61352}" type="datetimeFigureOut">
               <a:rPr lang="ko-KR" altLang="en-US" smtClean="0"/>
-              <a:t>2026-04-28</a:t>
+              <a:t>2026-05-08</a:t>
             </a:fld>
             <a:endParaRPr lang="ko-KR" altLang="en-US"/>
           </a:p>
@@ -1816,7 +1823,7 @@
           <a:p>
             <a:fld id="{48B2E156-3D9B-46D1-8B16-923D6BE61352}" type="datetimeFigureOut">
               <a:rPr lang="ko-KR" altLang="en-US" smtClean="0"/>
-              <a:t>2026-04-28</a:t>
+              <a:t>2026-05-08</a:t>
             </a:fld>
             <a:endParaRPr lang="ko-KR" altLang="en-US"/>
           </a:p>
@@ -1957,7 +1964,7 @@
           <a:p>
             <a:fld id="{48B2E156-3D9B-46D1-8B16-923D6BE61352}" type="datetimeFigureOut">
               <a:rPr lang="ko-KR" altLang="en-US" smtClean="0"/>
-              <a:t>2026-04-28</a:t>
+              <a:t>2026-05-08</a:t>
             </a:fld>
             <a:endParaRPr lang="ko-KR" altLang="en-US"/>
           </a:p>
@@ -2070,7 +2077,7 @@
           <a:p>
             <a:fld id="{48B2E156-3D9B-46D1-8B16-923D6BE61352}" type="datetimeFigureOut">
               <a:rPr lang="ko-KR" altLang="en-US" smtClean="0"/>
-              <a:t>2026-04-28</a:t>
+              <a:t>2026-05-08</a:t>
             </a:fld>
             <a:endParaRPr lang="ko-KR" altLang="en-US"/>
           </a:p>
@@ -2381,7 +2388,7 @@
           <a:p>
             <a:fld id="{48B2E156-3D9B-46D1-8B16-923D6BE61352}" type="datetimeFigureOut">
               <a:rPr lang="ko-KR" altLang="en-US" smtClean="0"/>
-              <a:t>2026-04-28</a:t>
+              <a:t>2026-05-08</a:t>
             </a:fld>
             <a:endParaRPr lang="ko-KR" altLang="en-US"/>
           </a:p>
@@ -2669,7 +2676,7 @@
           <a:p>
             <a:fld id="{48B2E156-3D9B-46D1-8B16-923D6BE61352}" type="datetimeFigureOut">
               <a:rPr lang="ko-KR" altLang="en-US" smtClean="0"/>
-              <a:t>2026-04-28</a:t>
+              <a:t>2026-05-08</a:t>
             </a:fld>
             <a:endParaRPr lang="ko-KR" altLang="en-US"/>
           </a:p>
@@ -2910,7 +2917,7 @@
           <a:p>
             <a:fld id="{48B2E156-3D9B-46D1-8B16-923D6BE61352}" type="datetimeFigureOut">
               <a:rPr lang="ko-KR" altLang="en-US" smtClean="0"/>
-              <a:t>2026-04-28</a:t>
+              <a:t>2026-05-08</a:t>
             </a:fld>
             <a:endParaRPr lang="ko-KR" altLang="en-US"/>
           </a:p>
@@ -3381,7 +3388,7 @@
                   <a:schemeClr val="tx1"/>
                 </a:solidFill>
               </a:rPr>
-              <a:t>Model Binary : Non Anim</a:t>
+              <a:t>Model Binary : Non Anim Model</a:t>
             </a:r>
             <a:endParaRPr lang="ko-KR" altLang="en-US" sz="3200" b="1" dirty="0">
               <a:solidFill>
@@ -7420,7 +7427,7 @@
                   <a:schemeClr val="tx1"/>
                 </a:solidFill>
               </a:rPr>
-              <a:t>Model Binary : Anim</a:t>
+              <a:t>Model Binary : Anim Model</a:t>
             </a:r>
             <a:endParaRPr lang="ko-KR" altLang="en-US" sz="3200" b="1" dirty="0">
               <a:solidFill>
@@ -13828,6 +13835,2713 @@
 </p:sld>
 </file>
 
+<file path=ppt/slides/slide8.xml><?xml version="1.0" encoding="utf-8"?>
+<p:sld xmlns:a="http://schemas.openxmlformats.org/drawingml/2006/main" xmlns:r="http://schemas.openxmlformats.org/officeDocument/2006/relationships" xmlns:p="http://schemas.openxmlformats.org/presentationml/2006/main">
+  <p:cSld>
+    <p:spTree>
+      <p:nvGrpSpPr>
+        <p:cNvPr id="1" name="">
+          <a:extLst>
+            <a:ext uri="{FF2B5EF4-FFF2-40B4-BE49-F238E27FC236}">
+              <a16:creationId xmlns:a16="http://schemas.microsoft.com/office/drawing/2014/main" id="{BEDDB4B8-2B8C-5BD0-9983-10DEF5F95ABC}"/>
+            </a:ext>
+          </a:extLst>
+        </p:cNvPr>
+        <p:cNvGrpSpPr/>
+        <p:nvPr/>
+      </p:nvGrpSpPr>
+      <p:grpSpPr>
+        <a:xfrm>
+          <a:off x="0" y="0"/>
+          <a:ext cx="0" cy="0"/>
+          <a:chOff x="0" y="0"/>
+          <a:chExt cx="0" cy="0"/>
+        </a:xfrm>
+      </p:grpSpPr>
+      <p:sp>
+        <p:nvSpPr>
+          <p:cNvPr id="5" name="직사각형 4">
+            <a:extLst>
+              <a:ext uri="{FF2B5EF4-FFF2-40B4-BE49-F238E27FC236}">
+                <a16:creationId xmlns:a16="http://schemas.microsoft.com/office/drawing/2014/main" id="{64802074-3D25-320D-2255-A580C9A0473E}"/>
+              </a:ext>
+            </a:extLst>
+          </p:cNvPr>
+          <p:cNvSpPr/>
+          <p:nvPr/>
+        </p:nvSpPr>
+        <p:spPr>
+          <a:xfrm>
+            <a:off x="4445392" y="647124"/>
+            <a:ext cx="7315198" cy="576774"/>
+          </a:xfrm>
+          <a:prstGeom prst="rect">
+            <a:avLst/>
+          </a:prstGeom>
+          <a:solidFill>
+            <a:schemeClr val="accent1">
+              <a:lumMod val="20000"/>
+              <a:lumOff val="80000"/>
+            </a:schemeClr>
+          </a:solidFill>
+        </p:spPr>
+        <p:style>
+          <a:lnRef idx="2">
+            <a:schemeClr val="accent1">
+              <a:shade val="15000"/>
+            </a:schemeClr>
+          </a:lnRef>
+          <a:fillRef idx="1">
+            <a:schemeClr val="accent1"/>
+          </a:fillRef>
+          <a:effectRef idx="0">
+            <a:schemeClr val="accent1"/>
+          </a:effectRef>
+          <a:fontRef idx="minor">
+            <a:schemeClr val="lt1"/>
+          </a:fontRef>
+        </p:style>
+        <p:txBody>
+          <a:bodyPr rtlCol="0" anchor="ctr"/>
+          <a:lstStyle/>
+          <a:p>
+            <a:pPr algn="ctr"/>
+            <a:r>
+              <a:rPr lang="en-US" altLang="ko-KR" sz="3200" b="1" dirty="0">
+                <a:solidFill>
+                  <a:schemeClr val="tx1"/>
+                </a:solidFill>
+              </a:rPr>
+              <a:t>Anim Binary : Animation</a:t>
+            </a:r>
+            <a:endParaRPr lang="ko-KR" altLang="en-US" sz="3200" b="1" dirty="0">
+              <a:solidFill>
+                <a:schemeClr val="tx1"/>
+              </a:solidFill>
+            </a:endParaRPr>
+          </a:p>
+        </p:txBody>
+      </p:sp>
+      <p:sp>
+        <p:nvSpPr>
+          <p:cNvPr id="8" name="직사각형 7">
+            <a:extLst>
+              <a:ext uri="{FF2B5EF4-FFF2-40B4-BE49-F238E27FC236}">
+                <a16:creationId xmlns:a16="http://schemas.microsoft.com/office/drawing/2014/main" id="{6B0CA7AE-5A57-B5D6-016E-5AE49F4B298D}"/>
+              </a:ext>
+            </a:extLst>
+          </p:cNvPr>
+          <p:cNvSpPr/>
+          <p:nvPr/>
+        </p:nvSpPr>
+        <p:spPr>
+          <a:xfrm>
+            <a:off x="4445392" y="1223898"/>
+            <a:ext cx="7315199" cy="576774"/>
+          </a:xfrm>
+          <a:prstGeom prst="rect">
+            <a:avLst/>
+          </a:prstGeom>
+          <a:solidFill>
+            <a:schemeClr val="accent1">
+              <a:lumMod val="20000"/>
+              <a:lumOff val="80000"/>
+            </a:schemeClr>
+          </a:solidFill>
+        </p:spPr>
+        <p:style>
+          <a:lnRef idx="2">
+            <a:schemeClr val="accent1">
+              <a:shade val="15000"/>
+            </a:schemeClr>
+          </a:lnRef>
+          <a:fillRef idx="1">
+            <a:schemeClr val="accent1"/>
+          </a:fillRef>
+          <a:effectRef idx="0">
+            <a:schemeClr val="accent1"/>
+          </a:effectRef>
+          <a:fontRef idx="minor">
+            <a:schemeClr val="lt1"/>
+          </a:fontRef>
+        </p:style>
+        <p:txBody>
+          <a:bodyPr rtlCol="0" anchor="ctr"/>
+          <a:lstStyle/>
+          <a:p>
+            <a:pPr algn="ctr"/>
+            <a:r>
+              <a:rPr lang="en-US" altLang="ko-KR" sz="2000" dirty="0">
+                <a:solidFill>
+                  <a:schemeClr val="tx1"/>
+                </a:solidFill>
+              </a:rPr>
+              <a:t>Header : FILEHEADERTYPE::FILEHEADER_ANIMAITON</a:t>
+            </a:r>
+            <a:endParaRPr lang="ko-KR" altLang="en-US" sz="2000" dirty="0">
+              <a:solidFill>
+                <a:schemeClr val="tx1"/>
+              </a:solidFill>
+            </a:endParaRPr>
+          </a:p>
+        </p:txBody>
+      </p:sp>
+      <p:sp>
+        <p:nvSpPr>
+          <p:cNvPr id="22" name="TextBox 21">
+            <a:extLst>
+              <a:ext uri="{FF2B5EF4-FFF2-40B4-BE49-F238E27FC236}">
+                <a16:creationId xmlns:a16="http://schemas.microsoft.com/office/drawing/2014/main" id="{B0C029C2-55DD-4510-D0F6-F020510C76C1}"/>
+              </a:ext>
+            </a:extLst>
+          </p:cNvPr>
+          <p:cNvSpPr txBox="1"/>
+          <p:nvPr/>
+        </p:nvSpPr>
+        <p:spPr>
+          <a:xfrm>
+            <a:off x="1891040" y="4776147"/>
+            <a:ext cx="7794752" cy="646331"/>
+          </a:xfrm>
+          <a:prstGeom prst="rect">
+            <a:avLst/>
+          </a:prstGeom>
+          <a:noFill/>
+        </p:spPr>
+        <p:txBody>
+          <a:bodyPr wrap="square" rtlCol="0">
+            <a:spAutoFit/>
+          </a:bodyPr>
+          <a:lstStyle/>
+          <a:p>
+            <a:pPr algn="ctr"/>
+            <a:r>
+              <a:rPr lang="ko-KR" altLang="en-US" dirty="0"/>
+              <a:t>각</a:t>
+            </a:r>
+            <a:r>
+              <a:rPr lang="en-US" altLang="ko-KR" dirty="0"/>
+              <a:t> </a:t>
+            </a:r>
+            <a:r>
+              <a:rPr lang="ko-KR" altLang="en-US" dirty="0"/>
+              <a:t>헤더 타입 마다 </a:t>
+            </a:r>
+            <a:r>
+              <a:rPr lang="en-US" altLang="ko-KR" dirty="0"/>
+              <a:t>CHUNCKTYPE</a:t>
+            </a:r>
+            <a:r>
+              <a:rPr lang="ko-KR" altLang="en-US" dirty="0"/>
+              <a:t>을 넣어줘야 한다</a:t>
+            </a:r>
+            <a:r>
+              <a:rPr lang="en-US" altLang="ko-KR" dirty="0"/>
+              <a:t>.</a:t>
+            </a:r>
+            <a:endParaRPr lang="ko-KR" altLang="en-US" dirty="0"/>
+          </a:p>
+          <a:p>
+            <a:pPr algn="ctr"/>
+            <a:endParaRPr lang="ko-KR" altLang="en-US" dirty="0"/>
+          </a:p>
+        </p:txBody>
+      </p:sp>
+      <p:pic>
+        <p:nvPicPr>
+          <p:cNvPr id="26" name="그림 25">
+            <a:extLst>
+              <a:ext uri="{FF2B5EF4-FFF2-40B4-BE49-F238E27FC236}">
+                <a16:creationId xmlns:a16="http://schemas.microsoft.com/office/drawing/2014/main" id="{AECA2FD6-B8BC-2F25-F2C0-3BBBBB73B35F}"/>
+              </a:ext>
+            </a:extLst>
+          </p:cNvPr>
+          <p:cNvPicPr>
+            <a:picLocks noChangeAspect="1"/>
+          </p:cNvPicPr>
+          <p:nvPr/>
+        </p:nvPicPr>
+        <p:blipFill>
+          <a:blip r:embed="rId2"/>
+          <a:stretch>
+            <a:fillRect/>
+          </a:stretch>
+        </p:blipFill>
+        <p:spPr>
+          <a:xfrm>
+            <a:off x="1891040" y="4335698"/>
+            <a:ext cx="7794752" cy="242390"/>
+          </a:xfrm>
+          <a:prstGeom prst="rect">
+            <a:avLst/>
+          </a:prstGeom>
+        </p:spPr>
+      </p:pic>
+      <p:cxnSp>
+        <p:nvCxnSpPr>
+          <p:cNvPr id="7" name="직선 화살표 연결선 6">
+            <a:extLst>
+              <a:ext uri="{FF2B5EF4-FFF2-40B4-BE49-F238E27FC236}">
+                <a16:creationId xmlns:a16="http://schemas.microsoft.com/office/drawing/2014/main" id="{FB4498D9-0139-7EFA-3860-4ABA30750872}"/>
+              </a:ext>
+            </a:extLst>
+          </p:cNvPr>
+          <p:cNvCxnSpPr/>
+          <p:nvPr/>
+        </p:nvCxnSpPr>
+        <p:spPr>
+          <a:xfrm>
+            <a:off x="8176862" y="1800672"/>
+            <a:ext cx="0" cy="295949"/>
+          </a:xfrm>
+          <a:prstGeom prst="straightConnector1">
+            <a:avLst/>
+          </a:prstGeom>
+          <a:ln>
+            <a:tailEnd type="triangle"/>
+          </a:ln>
+        </p:spPr>
+        <p:style>
+          <a:lnRef idx="2">
+            <a:schemeClr val="accent1"/>
+          </a:lnRef>
+          <a:fillRef idx="0">
+            <a:schemeClr val="accent1"/>
+          </a:fillRef>
+          <a:effectRef idx="1">
+            <a:schemeClr val="accent1"/>
+          </a:effectRef>
+          <a:fontRef idx="minor">
+            <a:schemeClr val="tx1"/>
+          </a:fontRef>
+        </p:style>
+      </p:cxnSp>
+      <p:sp>
+        <p:nvSpPr>
+          <p:cNvPr id="2" name="직사각형 1">
+            <a:extLst>
+              <a:ext uri="{FF2B5EF4-FFF2-40B4-BE49-F238E27FC236}">
+                <a16:creationId xmlns:a16="http://schemas.microsoft.com/office/drawing/2014/main" id="{08992FFF-079C-FCBF-E329-27AF16111AE0}"/>
+              </a:ext>
+            </a:extLst>
+          </p:cNvPr>
+          <p:cNvSpPr/>
+          <p:nvPr/>
+        </p:nvSpPr>
+        <p:spPr>
+          <a:xfrm>
+            <a:off x="4445392" y="2105337"/>
+            <a:ext cx="7315199" cy="576774"/>
+          </a:xfrm>
+          <a:prstGeom prst="rect">
+            <a:avLst/>
+          </a:prstGeom>
+          <a:solidFill>
+            <a:schemeClr val="accent1">
+              <a:lumMod val="20000"/>
+              <a:lumOff val="80000"/>
+            </a:schemeClr>
+          </a:solidFill>
+        </p:spPr>
+        <p:style>
+          <a:lnRef idx="2">
+            <a:schemeClr val="accent1">
+              <a:shade val="15000"/>
+            </a:schemeClr>
+          </a:lnRef>
+          <a:fillRef idx="1">
+            <a:schemeClr val="accent1"/>
+          </a:fillRef>
+          <a:effectRef idx="0">
+            <a:schemeClr val="accent1"/>
+          </a:effectRef>
+          <a:fontRef idx="minor">
+            <a:schemeClr val="lt1"/>
+          </a:fontRef>
+        </p:style>
+        <p:txBody>
+          <a:bodyPr rtlCol="0" anchor="ctr"/>
+          <a:lstStyle/>
+          <a:p>
+            <a:pPr algn="ctr"/>
+            <a:r>
+              <a:rPr lang="en-US" altLang="ko-KR" sz="2400" dirty="0">
+                <a:solidFill>
+                  <a:schemeClr val="tx1"/>
+                </a:solidFill>
+              </a:rPr>
+              <a:t>Animation Info</a:t>
+            </a:r>
+            <a:endParaRPr lang="ko-KR" altLang="en-US" sz="2400" dirty="0">
+              <a:solidFill>
+                <a:schemeClr val="tx1"/>
+              </a:solidFill>
+            </a:endParaRPr>
+          </a:p>
+        </p:txBody>
+      </p:sp>
+      <p:sp>
+        <p:nvSpPr>
+          <p:cNvPr id="6" name="TextBox 5">
+            <a:extLst>
+              <a:ext uri="{FF2B5EF4-FFF2-40B4-BE49-F238E27FC236}">
+                <a16:creationId xmlns:a16="http://schemas.microsoft.com/office/drawing/2014/main" id="{0111A69E-70B0-D88C-7EFE-3D5038BC853F}"/>
+              </a:ext>
+            </a:extLst>
+          </p:cNvPr>
+          <p:cNvSpPr txBox="1"/>
+          <p:nvPr/>
+        </p:nvSpPr>
+        <p:spPr>
+          <a:xfrm>
+            <a:off x="1891040" y="5099312"/>
+            <a:ext cx="8042232" cy="646331"/>
+          </a:xfrm>
+          <a:prstGeom prst="rect">
+            <a:avLst/>
+          </a:prstGeom>
+          <a:noFill/>
+        </p:spPr>
+        <p:txBody>
+          <a:bodyPr wrap="square" rtlCol="0">
+            <a:spAutoFit/>
+          </a:bodyPr>
+          <a:lstStyle/>
+          <a:p>
+            <a:pPr algn="ctr"/>
+            <a:r>
+              <a:rPr lang="en-US" altLang="ko-KR" dirty="0"/>
+              <a:t>Animation</a:t>
+            </a:r>
+            <a:r>
+              <a:rPr lang="ko-KR" altLang="en-US" dirty="0"/>
+              <a:t>을 읽기 위해서는 </a:t>
+            </a:r>
+            <a:r>
+              <a:rPr lang="en-US" altLang="ko-KR" dirty="0"/>
+              <a:t>Model</a:t>
+            </a:r>
+            <a:r>
+              <a:rPr lang="ko-KR" altLang="en-US" dirty="0"/>
+              <a:t>과 같이 들어있는 파일로 읽어줘야 한다</a:t>
+            </a:r>
+            <a:r>
+              <a:rPr lang="en-US" altLang="ko-KR" dirty="0"/>
+              <a:t>.</a:t>
+            </a:r>
+          </a:p>
+          <a:p>
+            <a:pPr algn="ctr"/>
+            <a:r>
+              <a:rPr lang="ko-KR" altLang="en-US" dirty="0"/>
+              <a:t>내가 그렇게 만들었다</a:t>
+            </a:r>
+            <a:endParaRPr lang="en-US" altLang="ko-KR" dirty="0"/>
+          </a:p>
+        </p:txBody>
+      </p:sp>
+      <p:pic>
+        <p:nvPicPr>
+          <p:cNvPr id="16" name="그림 15">
+            <a:extLst>
+              <a:ext uri="{FF2B5EF4-FFF2-40B4-BE49-F238E27FC236}">
+                <a16:creationId xmlns:a16="http://schemas.microsoft.com/office/drawing/2014/main" id="{9E5F6CC7-2AD5-7112-8B83-6D1F4A6613B5}"/>
+              </a:ext>
+            </a:extLst>
+          </p:cNvPr>
+          <p:cNvPicPr>
+            <a:picLocks noChangeAspect="1"/>
+          </p:cNvPicPr>
+          <p:nvPr/>
+        </p:nvPicPr>
+        <p:blipFill>
+          <a:blip r:embed="rId3"/>
+          <a:stretch>
+            <a:fillRect/>
+          </a:stretch>
+        </p:blipFill>
+        <p:spPr>
+          <a:xfrm>
+            <a:off x="5306292" y="180036"/>
+            <a:ext cx="5741140" cy="357403"/>
+          </a:xfrm>
+          <a:prstGeom prst="rect">
+            <a:avLst/>
+          </a:prstGeom>
+        </p:spPr>
+      </p:pic>
+    </p:spTree>
+    <p:extLst>
+      <p:ext uri="{BB962C8B-B14F-4D97-AF65-F5344CB8AC3E}">
+        <p14:creationId xmlns:p14="http://schemas.microsoft.com/office/powerpoint/2010/main" val="2286592100"/>
+      </p:ext>
+    </p:extLst>
+  </p:cSld>
+  <p:clrMapOvr>
+    <a:masterClrMapping/>
+  </p:clrMapOvr>
+</p:sld>
+</file>
+
+<file path=ppt/slides/slide9.xml><?xml version="1.0" encoding="utf-8"?>
+<p:sld xmlns:a="http://schemas.openxmlformats.org/drawingml/2006/main" xmlns:r="http://schemas.openxmlformats.org/officeDocument/2006/relationships" xmlns:p="http://schemas.openxmlformats.org/presentationml/2006/main">
+  <p:cSld>
+    <p:spTree>
+      <p:nvGrpSpPr>
+        <p:cNvPr id="1" name="">
+          <a:extLst>
+            <a:ext uri="{FF2B5EF4-FFF2-40B4-BE49-F238E27FC236}">
+              <a16:creationId xmlns:a16="http://schemas.microsoft.com/office/drawing/2014/main" id="{D0EB8124-553D-A2ED-FE5C-6021EAA5CBFA}"/>
+            </a:ext>
+          </a:extLst>
+        </p:cNvPr>
+        <p:cNvGrpSpPr/>
+        <p:nvPr/>
+      </p:nvGrpSpPr>
+      <p:grpSpPr>
+        <a:xfrm>
+          <a:off x="0" y="0"/>
+          <a:ext cx="0" cy="0"/>
+          <a:chOff x="0" y="0"/>
+          <a:chExt cx="0" cy="0"/>
+        </a:xfrm>
+      </p:grpSpPr>
+      <p:grpSp>
+        <p:nvGrpSpPr>
+          <p:cNvPr id="10" name="그룹 9">
+            <a:extLst>
+              <a:ext uri="{FF2B5EF4-FFF2-40B4-BE49-F238E27FC236}">
+                <a16:creationId xmlns:a16="http://schemas.microsoft.com/office/drawing/2014/main" id="{3C97E1E8-03A6-A2EA-2C63-10C48EFA9ECF}"/>
+              </a:ext>
+            </a:extLst>
+          </p:cNvPr>
+          <p:cNvGrpSpPr/>
+          <p:nvPr/>
+        </p:nvGrpSpPr>
+        <p:grpSpPr>
+          <a:xfrm>
+            <a:off x="198456" y="749459"/>
+            <a:ext cx="7287805" cy="455976"/>
+            <a:chOff x="1057298" y="923087"/>
+            <a:chExt cx="9206317" cy="576774"/>
+          </a:xfrm>
+        </p:grpSpPr>
+        <p:sp>
+          <p:nvSpPr>
+            <p:cNvPr id="7" name="직사각형 6">
+              <a:extLst>
+                <a:ext uri="{FF2B5EF4-FFF2-40B4-BE49-F238E27FC236}">
+                  <a16:creationId xmlns:a16="http://schemas.microsoft.com/office/drawing/2014/main" id="{9B53E926-8503-7EA2-103E-9E196BD9BD86}"/>
+                </a:ext>
+              </a:extLst>
+            </p:cNvPr>
+            <p:cNvSpPr/>
+            <p:nvPr/>
+          </p:nvSpPr>
+          <p:spPr>
+            <a:xfrm>
+              <a:off x="1057298" y="923087"/>
+              <a:ext cx="7518811" cy="576774"/>
+            </a:xfrm>
+            <a:prstGeom prst="rect">
+              <a:avLst/>
+            </a:prstGeom>
+            <a:solidFill>
+              <a:schemeClr val="accent1">
+                <a:lumMod val="20000"/>
+                <a:lumOff val="80000"/>
+              </a:schemeClr>
+            </a:solidFill>
+          </p:spPr>
+          <p:style>
+            <a:lnRef idx="2">
+              <a:schemeClr val="accent1">
+                <a:shade val="15000"/>
+              </a:schemeClr>
+            </a:lnRef>
+            <a:fillRef idx="1">
+              <a:schemeClr val="accent1"/>
+            </a:fillRef>
+            <a:effectRef idx="0">
+              <a:schemeClr val="accent1"/>
+            </a:effectRef>
+            <a:fontRef idx="minor">
+              <a:schemeClr val="lt1"/>
+            </a:fontRef>
+          </p:style>
+          <p:txBody>
+            <a:bodyPr rtlCol="0" anchor="ctr"/>
+            <a:lstStyle/>
+            <a:p>
+              <a:pPr algn="ctr"/>
+              <a:r>
+                <a:rPr lang="en-US" altLang="ko-KR" sz="1600" dirty="0">
+                  <a:solidFill>
+                    <a:schemeClr val="tx1"/>
+                  </a:solidFill>
+                </a:rPr>
+                <a:t>Header : CHUNCKTYPE::CHUNCK_ANIMAITON</a:t>
+              </a:r>
+              <a:endParaRPr lang="ko-KR" altLang="en-US" sz="1600" dirty="0">
+                <a:solidFill>
+                  <a:schemeClr val="tx1"/>
+                </a:solidFill>
+              </a:endParaRPr>
+            </a:p>
+          </p:txBody>
+        </p:sp>
+        <p:sp>
+          <p:nvSpPr>
+            <p:cNvPr id="8" name="직사각형 7">
+              <a:extLst>
+                <a:ext uri="{FF2B5EF4-FFF2-40B4-BE49-F238E27FC236}">
+                  <a16:creationId xmlns:a16="http://schemas.microsoft.com/office/drawing/2014/main" id="{D89C0A5A-994A-35AA-1E14-8D381FCDF1A0}"/>
+                </a:ext>
+              </a:extLst>
+            </p:cNvPr>
+            <p:cNvSpPr/>
+            <p:nvPr/>
+          </p:nvSpPr>
+          <p:spPr>
+            <a:xfrm>
+              <a:off x="8576109" y="923087"/>
+              <a:ext cx="1687506" cy="576774"/>
+            </a:xfrm>
+            <a:prstGeom prst="rect">
+              <a:avLst/>
+            </a:prstGeom>
+            <a:solidFill>
+              <a:schemeClr val="accent1">
+                <a:lumMod val="20000"/>
+                <a:lumOff val="80000"/>
+              </a:schemeClr>
+            </a:solidFill>
+          </p:spPr>
+          <p:style>
+            <a:lnRef idx="2">
+              <a:schemeClr val="accent1">
+                <a:shade val="15000"/>
+              </a:schemeClr>
+            </a:lnRef>
+            <a:fillRef idx="1">
+              <a:schemeClr val="accent1"/>
+            </a:fillRef>
+            <a:effectRef idx="0">
+              <a:schemeClr val="accent1"/>
+            </a:effectRef>
+            <a:fontRef idx="minor">
+              <a:schemeClr val="lt1"/>
+            </a:fontRef>
+          </p:style>
+          <p:txBody>
+            <a:bodyPr rtlCol="0" anchor="ctr"/>
+            <a:lstStyle/>
+            <a:p>
+              <a:pPr algn="ctr"/>
+              <a:r>
+                <a:rPr lang="en-US" altLang="ko-KR" sz="1600" dirty="0">
+                  <a:solidFill>
+                    <a:schemeClr val="tx1"/>
+                  </a:solidFill>
+                </a:rPr>
+                <a:t>uint32_t</a:t>
+              </a:r>
+              <a:endParaRPr lang="ko-KR" altLang="en-US" sz="1600" dirty="0">
+                <a:solidFill>
+                  <a:schemeClr val="tx1"/>
+                </a:solidFill>
+              </a:endParaRPr>
+            </a:p>
+          </p:txBody>
+        </p:sp>
+      </p:grpSp>
+      <p:grpSp>
+        <p:nvGrpSpPr>
+          <p:cNvPr id="12" name="그룹 11">
+            <a:extLst>
+              <a:ext uri="{FF2B5EF4-FFF2-40B4-BE49-F238E27FC236}">
+                <a16:creationId xmlns:a16="http://schemas.microsoft.com/office/drawing/2014/main" id="{630E5133-9697-9BD7-5423-84C61A67F24C}"/>
+              </a:ext>
+            </a:extLst>
+          </p:cNvPr>
+          <p:cNvGrpSpPr/>
+          <p:nvPr/>
+        </p:nvGrpSpPr>
+        <p:grpSpPr>
+          <a:xfrm>
+            <a:off x="198456" y="284696"/>
+            <a:ext cx="7287805" cy="464763"/>
+            <a:chOff x="1057298" y="335198"/>
+            <a:chExt cx="9206317" cy="587889"/>
+          </a:xfrm>
+        </p:grpSpPr>
+        <p:sp>
+          <p:nvSpPr>
+            <p:cNvPr id="4" name="직사각형 3">
+              <a:extLst>
+                <a:ext uri="{FF2B5EF4-FFF2-40B4-BE49-F238E27FC236}">
+                  <a16:creationId xmlns:a16="http://schemas.microsoft.com/office/drawing/2014/main" id="{B76D41B2-077A-E4E2-CD64-7CD53ACACEA4}"/>
+                </a:ext>
+              </a:extLst>
+            </p:cNvPr>
+            <p:cNvSpPr/>
+            <p:nvPr/>
+          </p:nvSpPr>
+          <p:spPr>
+            <a:xfrm>
+              <a:off x="1057298" y="335198"/>
+              <a:ext cx="7518811" cy="576774"/>
+            </a:xfrm>
+            <a:prstGeom prst="rect">
+              <a:avLst/>
+            </a:prstGeom>
+            <a:solidFill>
+              <a:schemeClr val="accent1">
+                <a:lumMod val="20000"/>
+                <a:lumOff val="80000"/>
+              </a:schemeClr>
+            </a:solidFill>
+          </p:spPr>
+          <p:style>
+            <a:lnRef idx="2">
+              <a:schemeClr val="accent1">
+                <a:shade val="15000"/>
+              </a:schemeClr>
+            </a:lnRef>
+            <a:fillRef idx="1">
+              <a:schemeClr val="accent1"/>
+            </a:fillRef>
+            <a:effectRef idx="0">
+              <a:schemeClr val="accent1"/>
+            </a:effectRef>
+            <a:fontRef idx="minor">
+              <a:schemeClr val="lt1"/>
+            </a:fontRef>
+          </p:style>
+          <p:txBody>
+            <a:bodyPr rtlCol="0" anchor="ctr"/>
+            <a:lstStyle/>
+            <a:p>
+              <a:pPr algn="ctr"/>
+              <a:r>
+                <a:rPr lang="en-US" altLang="ko-KR" sz="2000" b="1" dirty="0">
+                  <a:solidFill>
+                    <a:schemeClr val="tx1"/>
+                  </a:solidFill>
+                </a:rPr>
+                <a:t>ANIMATION</a:t>
+              </a:r>
+              <a:endParaRPr lang="ko-KR" altLang="en-US" sz="2000" b="1" dirty="0">
+                <a:solidFill>
+                  <a:schemeClr val="tx1"/>
+                </a:solidFill>
+              </a:endParaRPr>
+            </a:p>
+          </p:txBody>
+        </p:sp>
+        <p:sp>
+          <p:nvSpPr>
+            <p:cNvPr id="11" name="직사각형 10">
+              <a:extLst>
+                <a:ext uri="{FF2B5EF4-FFF2-40B4-BE49-F238E27FC236}">
+                  <a16:creationId xmlns:a16="http://schemas.microsoft.com/office/drawing/2014/main" id="{7643868A-319F-53C3-7329-A49391566694}"/>
+                </a:ext>
+              </a:extLst>
+            </p:cNvPr>
+            <p:cNvSpPr/>
+            <p:nvPr/>
+          </p:nvSpPr>
+          <p:spPr>
+            <a:xfrm>
+              <a:off x="8576110" y="346313"/>
+              <a:ext cx="1687505" cy="576774"/>
+            </a:xfrm>
+            <a:prstGeom prst="rect">
+              <a:avLst/>
+            </a:prstGeom>
+            <a:solidFill>
+              <a:schemeClr val="accent1">
+                <a:lumMod val="20000"/>
+                <a:lumOff val="80000"/>
+              </a:schemeClr>
+            </a:solidFill>
+          </p:spPr>
+          <p:style>
+            <a:lnRef idx="2">
+              <a:schemeClr val="accent1">
+                <a:shade val="15000"/>
+              </a:schemeClr>
+            </a:lnRef>
+            <a:fillRef idx="1">
+              <a:schemeClr val="accent1"/>
+            </a:fillRef>
+            <a:effectRef idx="0">
+              <a:schemeClr val="accent1"/>
+            </a:effectRef>
+            <a:fontRef idx="minor">
+              <a:schemeClr val="lt1"/>
+            </a:fontRef>
+          </p:style>
+          <p:txBody>
+            <a:bodyPr rtlCol="0" anchor="ctr"/>
+            <a:lstStyle/>
+            <a:p>
+              <a:pPr algn="ctr"/>
+              <a:r>
+                <a:rPr lang="en-US" altLang="ko-KR" sz="1400" b="1" dirty="0">
+                  <a:solidFill>
+                    <a:schemeClr val="tx1"/>
+                  </a:solidFill>
+                </a:rPr>
+                <a:t>TYPE</a:t>
+              </a:r>
+              <a:endParaRPr lang="ko-KR" altLang="en-US" sz="1400" b="1" dirty="0">
+                <a:solidFill>
+                  <a:schemeClr val="tx1"/>
+                </a:solidFill>
+              </a:endParaRPr>
+            </a:p>
+          </p:txBody>
+        </p:sp>
+      </p:grpSp>
+      <p:grpSp>
+        <p:nvGrpSpPr>
+          <p:cNvPr id="13" name="그룹 12">
+            <a:extLst>
+              <a:ext uri="{FF2B5EF4-FFF2-40B4-BE49-F238E27FC236}">
+                <a16:creationId xmlns:a16="http://schemas.microsoft.com/office/drawing/2014/main" id="{306F8DF2-D32F-2B87-6EF7-B67EED68004E}"/>
+              </a:ext>
+            </a:extLst>
+          </p:cNvPr>
+          <p:cNvGrpSpPr/>
+          <p:nvPr/>
+        </p:nvGrpSpPr>
+        <p:grpSpPr>
+          <a:xfrm>
+            <a:off x="198456" y="1214223"/>
+            <a:ext cx="7287805" cy="455976"/>
+            <a:chOff x="1057298" y="923087"/>
+            <a:chExt cx="9206317" cy="576774"/>
+          </a:xfrm>
+        </p:grpSpPr>
+        <p:sp>
+          <p:nvSpPr>
+            <p:cNvPr id="14" name="직사각형 13">
+              <a:extLst>
+                <a:ext uri="{FF2B5EF4-FFF2-40B4-BE49-F238E27FC236}">
+                  <a16:creationId xmlns:a16="http://schemas.microsoft.com/office/drawing/2014/main" id="{7B7A856E-373F-FC6E-21AF-628346BD8AFA}"/>
+                </a:ext>
+              </a:extLst>
+            </p:cNvPr>
+            <p:cNvSpPr/>
+            <p:nvPr/>
+          </p:nvSpPr>
+          <p:spPr>
+            <a:xfrm>
+              <a:off x="1057298" y="923087"/>
+              <a:ext cx="7518811" cy="576774"/>
+            </a:xfrm>
+            <a:prstGeom prst="rect">
+              <a:avLst/>
+            </a:prstGeom>
+            <a:solidFill>
+              <a:schemeClr val="accent1">
+                <a:lumMod val="20000"/>
+                <a:lumOff val="80000"/>
+              </a:schemeClr>
+            </a:solidFill>
+          </p:spPr>
+          <p:style>
+            <a:lnRef idx="2">
+              <a:schemeClr val="accent1">
+                <a:shade val="15000"/>
+              </a:schemeClr>
+            </a:lnRef>
+            <a:fillRef idx="1">
+              <a:schemeClr val="accent1"/>
+            </a:fillRef>
+            <a:effectRef idx="0">
+              <a:schemeClr val="accent1"/>
+            </a:effectRef>
+            <a:fontRef idx="minor">
+              <a:schemeClr val="lt1"/>
+            </a:fontRef>
+          </p:style>
+          <p:txBody>
+            <a:bodyPr rtlCol="0" anchor="ctr"/>
+            <a:lstStyle/>
+            <a:p>
+              <a:pPr algn="ctr"/>
+              <a:r>
+                <a:rPr lang="en-US" altLang="ko-KR" sz="1600" dirty="0">
+                  <a:solidFill>
+                    <a:schemeClr val="tx1"/>
+                  </a:solidFill>
+                </a:rPr>
+                <a:t>Data : Animation Count</a:t>
+              </a:r>
+              <a:endParaRPr lang="ko-KR" altLang="en-US" sz="1600" dirty="0">
+                <a:solidFill>
+                  <a:schemeClr val="tx1"/>
+                </a:solidFill>
+              </a:endParaRPr>
+            </a:p>
+          </p:txBody>
+        </p:sp>
+        <p:sp>
+          <p:nvSpPr>
+            <p:cNvPr id="15" name="직사각형 14">
+              <a:extLst>
+                <a:ext uri="{FF2B5EF4-FFF2-40B4-BE49-F238E27FC236}">
+                  <a16:creationId xmlns:a16="http://schemas.microsoft.com/office/drawing/2014/main" id="{7202C30D-4C25-AB7B-F650-D71C4075AD75}"/>
+                </a:ext>
+              </a:extLst>
+            </p:cNvPr>
+            <p:cNvSpPr/>
+            <p:nvPr/>
+          </p:nvSpPr>
+          <p:spPr>
+            <a:xfrm>
+              <a:off x="8576109" y="923087"/>
+              <a:ext cx="1687506" cy="576774"/>
+            </a:xfrm>
+            <a:prstGeom prst="rect">
+              <a:avLst/>
+            </a:prstGeom>
+            <a:solidFill>
+              <a:schemeClr val="accent1">
+                <a:lumMod val="20000"/>
+                <a:lumOff val="80000"/>
+              </a:schemeClr>
+            </a:solidFill>
+          </p:spPr>
+          <p:style>
+            <a:lnRef idx="2">
+              <a:schemeClr val="accent1">
+                <a:shade val="15000"/>
+              </a:schemeClr>
+            </a:lnRef>
+            <a:fillRef idx="1">
+              <a:schemeClr val="accent1"/>
+            </a:fillRef>
+            <a:effectRef idx="0">
+              <a:schemeClr val="accent1"/>
+            </a:effectRef>
+            <a:fontRef idx="minor">
+              <a:schemeClr val="lt1"/>
+            </a:fontRef>
+          </p:style>
+          <p:txBody>
+            <a:bodyPr rtlCol="0" anchor="ctr"/>
+            <a:lstStyle/>
+            <a:p>
+              <a:pPr algn="ctr"/>
+              <a:r>
+                <a:rPr lang="en-US" altLang="ko-KR" sz="1600" dirty="0">
+                  <a:solidFill>
+                    <a:schemeClr val="tx1"/>
+                  </a:solidFill>
+                </a:rPr>
+                <a:t>uint32_t</a:t>
+              </a:r>
+              <a:endParaRPr lang="ko-KR" altLang="en-US" sz="1600" dirty="0">
+                <a:solidFill>
+                  <a:schemeClr val="tx1"/>
+                </a:solidFill>
+              </a:endParaRPr>
+            </a:p>
+          </p:txBody>
+        </p:sp>
+      </p:grpSp>
+      <p:cxnSp>
+        <p:nvCxnSpPr>
+          <p:cNvPr id="17" name="직선 화살표 연결선 16">
+            <a:extLst>
+              <a:ext uri="{FF2B5EF4-FFF2-40B4-BE49-F238E27FC236}">
+                <a16:creationId xmlns:a16="http://schemas.microsoft.com/office/drawing/2014/main" id="{40E8E061-FF56-FFF6-0678-C7F4ACDA87B4}"/>
+              </a:ext>
+            </a:extLst>
+          </p:cNvPr>
+          <p:cNvCxnSpPr>
+            <a:cxnSpLocks/>
+            <a:stCxn id="14" idx="2"/>
+            <a:endCxn id="21" idx="0"/>
+          </p:cNvCxnSpPr>
+          <p:nvPr/>
+        </p:nvCxnSpPr>
+        <p:spPr>
+          <a:xfrm flipH="1">
+            <a:off x="3174435" y="1670199"/>
+            <a:ext cx="1" cy="384910"/>
+          </a:xfrm>
+          <a:prstGeom prst="straightConnector1">
+            <a:avLst/>
+          </a:prstGeom>
+          <a:ln>
+            <a:tailEnd type="triangle"/>
+          </a:ln>
+        </p:spPr>
+        <p:style>
+          <a:lnRef idx="2">
+            <a:schemeClr val="accent1"/>
+          </a:lnRef>
+          <a:fillRef idx="0">
+            <a:schemeClr val="accent1"/>
+          </a:fillRef>
+          <a:effectRef idx="1">
+            <a:schemeClr val="accent1"/>
+          </a:effectRef>
+          <a:fontRef idx="minor">
+            <a:schemeClr val="tx1"/>
+          </a:fontRef>
+        </p:style>
+      </p:cxnSp>
+      <p:sp>
+        <p:nvSpPr>
+          <p:cNvPr id="19" name="TextBox 18">
+            <a:extLst>
+              <a:ext uri="{FF2B5EF4-FFF2-40B4-BE49-F238E27FC236}">
+                <a16:creationId xmlns:a16="http://schemas.microsoft.com/office/drawing/2014/main" id="{3617316F-2B69-E254-5C17-ED9E689801B3}"/>
+              </a:ext>
+            </a:extLst>
+          </p:cNvPr>
+          <p:cNvSpPr txBox="1"/>
+          <p:nvPr/>
+        </p:nvSpPr>
+        <p:spPr>
+          <a:xfrm>
+            <a:off x="3392175" y="1678987"/>
+            <a:ext cx="3672768" cy="338554"/>
+          </a:xfrm>
+          <a:prstGeom prst="rect">
+            <a:avLst/>
+          </a:prstGeom>
+          <a:noFill/>
+        </p:spPr>
+        <p:txBody>
+          <a:bodyPr wrap="square" rtlCol="0">
+            <a:spAutoFit/>
+          </a:bodyPr>
+          <a:lstStyle/>
+          <a:p>
+            <a:r>
+              <a:rPr lang="en-US" altLang="ko-KR" sz="1600" dirty="0"/>
+              <a:t>LOOP DATA : Animation Count</a:t>
+            </a:r>
+            <a:endParaRPr lang="ko-KR" altLang="en-US" sz="1600" dirty="0"/>
+          </a:p>
+        </p:txBody>
+      </p:sp>
+      <p:grpSp>
+        <p:nvGrpSpPr>
+          <p:cNvPr id="20" name="그룹 19">
+            <a:extLst>
+              <a:ext uri="{FF2B5EF4-FFF2-40B4-BE49-F238E27FC236}">
+                <a16:creationId xmlns:a16="http://schemas.microsoft.com/office/drawing/2014/main" id="{EC6CB7D8-163B-B551-D8F3-7CA0DF6DB720}"/>
+              </a:ext>
+            </a:extLst>
+          </p:cNvPr>
+          <p:cNvGrpSpPr/>
+          <p:nvPr/>
+        </p:nvGrpSpPr>
+        <p:grpSpPr>
+          <a:xfrm>
+            <a:off x="198455" y="2055109"/>
+            <a:ext cx="7287805" cy="455976"/>
+            <a:chOff x="1057298" y="923087"/>
+            <a:chExt cx="9206317" cy="576774"/>
+          </a:xfrm>
+        </p:grpSpPr>
+        <p:sp>
+          <p:nvSpPr>
+            <p:cNvPr id="21" name="직사각형 20">
+              <a:extLst>
+                <a:ext uri="{FF2B5EF4-FFF2-40B4-BE49-F238E27FC236}">
+                  <a16:creationId xmlns:a16="http://schemas.microsoft.com/office/drawing/2014/main" id="{1E622A24-041D-F8E2-4B71-E1FEC6FDA1B9}"/>
+                </a:ext>
+              </a:extLst>
+            </p:cNvPr>
+            <p:cNvSpPr/>
+            <p:nvPr/>
+          </p:nvSpPr>
+          <p:spPr>
+            <a:xfrm>
+              <a:off x="1057298" y="923087"/>
+              <a:ext cx="7518811" cy="576774"/>
+            </a:xfrm>
+            <a:prstGeom prst="rect">
+              <a:avLst/>
+            </a:prstGeom>
+            <a:solidFill>
+              <a:schemeClr val="accent1">
+                <a:lumMod val="20000"/>
+                <a:lumOff val="80000"/>
+              </a:schemeClr>
+            </a:solidFill>
+          </p:spPr>
+          <p:style>
+            <a:lnRef idx="2">
+              <a:schemeClr val="accent1">
+                <a:shade val="15000"/>
+              </a:schemeClr>
+            </a:lnRef>
+            <a:fillRef idx="1">
+              <a:schemeClr val="accent1"/>
+            </a:fillRef>
+            <a:effectRef idx="0">
+              <a:schemeClr val="accent1"/>
+            </a:effectRef>
+            <a:fontRef idx="minor">
+              <a:schemeClr val="lt1"/>
+            </a:fontRef>
+          </p:style>
+          <p:txBody>
+            <a:bodyPr rtlCol="0" anchor="ctr"/>
+            <a:lstStyle/>
+            <a:p>
+              <a:pPr algn="ctr"/>
+              <a:r>
+                <a:rPr lang="en-US" altLang="ko-KR" sz="1600" dirty="0">
+                  <a:solidFill>
+                    <a:schemeClr val="tx1"/>
+                  </a:solidFill>
+                </a:rPr>
+                <a:t>Data : Animation Duration</a:t>
+              </a:r>
+              <a:endParaRPr lang="ko-KR" altLang="en-US" sz="1600" dirty="0">
+                <a:solidFill>
+                  <a:schemeClr val="tx1"/>
+                </a:solidFill>
+              </a:endParaRPr>
+            </a:p>
+          </p:txBody>
+        </p:sp>
+        <p:sp>
+          <p:nvSpPr>
+            <p:cNvPr id="22" name="직사각형 21">
+              <a:extLst>
+                <a:ext uri="{FF2B5EF4-FFF2-40B4-BE49-F238E27FC236}">
+                  <a16:creationId xmlns:a16="http://schemas.microsoft.com/office/drawing/2014/main" id="{BF08CB1B-B7E9-4D13-5DC4-FD91FDED8986}"/>
+                </a:ext>
+              </a:extLst>
+            </p:cNvPr>
+            <p:cNvSpPr/>
+            <p:nvPr/>
+          </p:nvSpPr>
+          <p:spPr>
+            <a:xfrm>
+              <a:off x="8576109" y="923087"/>
+              <a:ext cx="1687506" cy="576774"/>
+            </a:xfrm>
+            <a:prstGeom prst="rect">
+              <a:avLst/>
+            </a:prstGeom>
+            <a:solidFill>
+              <a:schemeClr val="accent1">
+                <a:lumMod val="20000"/>
+                <a:lumOff val="80000"/>
+              </a:schemeClr>
+            </a:solidFill>
+          </p:spPr>
+          <p:style>
+            <a:lnRef idx="2">
+              <a:schemeClr val="accent1">
+                <a:shade val="15000"/>
+              </a:schemeClr>
+            </a:lnRef>
+            <a:fillRef idx="1">
+              <a:schemeClr val="accent1"/>
+            </a:fillRef>
+            <a:effectRef idx="0">
+              <a:schemeClr val="accent1"/>
+            </a:effectRef>
+            <a:fontRef idx="minor">
+              <a:schemeClr val="lt1"/>
+            </a:fontRef>
+          </p:style>
+          <p:txBody>
+            <a:bodyPr rtlCol="0" anchor="ctr"/>
+            <a:lstStyle/>
+            <a:p>
+              <a:pPr algn="ctr"/>
+              <a:r>
+                <a:rPr lang="en-US" altLang="ko-KR" sz="1600" dirty="0">
+                  <a:solidFill>
+                    <a:schemeClr val="tx1"/>
+                  </a:solidFill>
+                </a:rPr>
+                <a:t>float</a:t>
+              </a:r>
+              <a:endParaRPr lang="ko-KR" altLang="en-US" sz="1600" dirty="0">
+                <a:solidFill>
+                  <a:schemeClr val="tx1"/>
+                </a:solidFill>
+              </a:endParaRPr>
+            </a:p>
+          </p:txBody>
+        </p:sp>
+      </p:grpSp>
+      <p:grpSp>
+        <p:nvGrpSpPr>
+          <p:cNvPr id="23" name="그룹 22">
+            <a:extLst>
+              <a:ext uri="{FF2B5EF4-FFF2-40B4-BE49-F238E27FC236}">
+                <a16:creationId xmlns:a16="http://schemas.microsoft.com/office/drawing/2014/main" id="{B7DCEBEF-14D1-5A4B-D3D8-D582AB4EC842}"/>
+              </a:ext>
+            </a:extLst>
+          </p:cNvPr>
+          <p:cNvGrpSpPr/>
+          <p:nvPr/>
+        </p:nvGrpSpPr>
+        <p:grpSpPr>
+          <a:xfrm>
+            <a:off x="198455" y="2511085"/>
+            <a:ext cx="7287805" cy="455976"/>
+            <a:chOff x="1057298" y="923087"/>
+            <a:chExt cx="9206317" cy="576774"/>
+          </a:xfrm>
+        </p:grpSpPr>
+        <p:sp>
+          <p:nvSpPr>
+            <p:cNvPr id="24" name="직사각형 23">
+              <a:extLst>
+                <a:ext uri="{FF2B5EF4-FFF2-40B4-BE49-F238E27FC236}">
+                  <a16:creationId xmlns:a16="http://schemas.microsoft.com/office/drawing/2014/main" id="{FFDF9C19-AB28-E267-78E5-FB02B4041675}"/>
+                </a:ext>
+              </a:extLst>
+            </p:cNvPr>
+            <p:cNvSpPr/>
+            <p:nvPr/>
+          </p:nvSpPr>
+          <p:spPr>
+            <a:xfrm>
+              <a:off x="1057298" y="923087"/>
+              <a:ext cx="7518811" cy="576774"/>
+            </a:xfrm>
+            <a:prstGeom prst="rect">
+              <a:avLst/>
+            </a:prstGeom>
+            <a:solidFill>
+              <a:schemeClr val="accent1">
+                <a:lumMod val="20000"/>
+                <a:lumOff val="80000"/>
+              </a:schemeClr>
+            </a:solidFill>
+          </p:spPr>
+          <p:style>
+            <a:lnRef idx="2">
+              <a:schemeClr val="accent1">
+                <a:shade val="15000"/>
+              </a:schemeClr>
+            </a:lnRef>
+            <a:fillRef idx="1">
+              <a:schemeClr val="accent1"/>
+            </a:fillRef>
+            <a:effectRef idx="0">
+              <a:schemeClr val="accent1"/>
+            </a:effectRef>
+            <a:fontRef idx="minor">
+              <a:schemeClr val="lt1"/>
+            </a:fontRef>
+          </p:style>
+          <p:txBody>
+            <a:bodyPr rtlCol="0" anchor="ctr"/>
+            <a:lstStyle/>
+            <a:p>
+              <a:pPr algn="ctr"/>
+              <a:r>
+                <a:rPr lang="en-US" altLang="ko-KR" sz="1600" dirty="0">
+                  <a:solidFill>
+                    <a:schemeClr val="tx1"/>
+                  </a:solidFill>
+                </a:rPr>
+                <a:t>Data : Animation Tick Per Second</a:t>
+              </a:r>
+              <a:endParaRPr lang="ko-KR" altLang="en-US" sz="1600" dirty="0">
+                <a:solidFill>
+                  <a:schemeClr val="tx1"/>
+                </a:solidFill>
+              </a:endParaRPr>
+            </a:p>
+          </p:txBody>
+        </p:sp>
+        <p:sp>
+          <p:nvSpPr>
+            <p:cNvPr id="25" name="직사각형 24">
+              <a:extLst>
+                <a:ext uri="{FF2B5EF4-FFF2-40B4-BE49-F238E27FC236}">
+                  <a16:creationId xmlns:a16="http://schemas.microsoft.com/office/drawing/2014/main" id="{08B83BDF-CB72-36BE-DC8B-BB5C42589D91}"/>
+                </a:ext>
+              </a:extLst>
+            </p:cNvPr>
+            <p:cNvSpPr/>
+            <p:nvPr/>
+          </p:nvSpPr>
+          <p:spPr>
+            <a:xfrm>
+              <a:off x="8576109" y="923087"/>
+              <a:ext cx="1687506" cy="576774"/>
+            </a:xfrm>
+            <a:prstGeom prst="rect">
+              <a:avLst/>
+            </a:prstGeom>
+            <a:solidFill>
+              <a:schemeClr val="accent1">
+                <a:lumMod val="20000"/>
+                <a:lumOff val="80000"/>
+              </a:schemeClr>
+            </a:solidFill>
+          </p:spPr>
+          <p:style>
+            <a:lnRef idx="2">
+              <a:schemeClr val="accent1">
+                <a:shade val="15000"/>
+              </a:schemeClr>
+            </a:lnRef>
+            <a:fillRef idx="1">
+              <a:schemeClr val="accent1"/>
+            </a:fillRef>
+            <a:effectRef idx="0">
+              <a:schemeClr val="accent1"/>
+            </a:effectRef>
+            <a:fontRef idx="minor">
+              <a:schemeClr val="lt1"/>
+            </a:fontRef>
+          </p:style>
+          <p:txBody>
+            <a:bodyPr rtlCol="0" anchor="ctr"/>
+            <a:lstStyle/>
+            <a:p>
+              <a:pPr algn="ctr"/>
+              <a:r>
+                <a:rPr lang="en-US" altLang="ko-KR" sz="1600" dirty="0">
+                  <a:solidFill>
+                    <a:schemeClr val="tx1"/>
+                  </a:solidFill>
+                </a:rPr>
+                <a:t>float</a:t>
+              </a:r>
+              <a:endParaRPr lang="ko-KR" altLang="en-US" sz="1600" dirty="0">
+                <a:solidFill>
+                  <a:schemeClr val="tx1"/>
+                </a:solidFill>
+              </a:endParaRPr>
+            </a:p>
+          </p:txBody>
+        </p:sp>
+      </p:grpSp>
+      <p:sp>
+        <p:nvSpPr>
+          <p:cNvPr id="55" name="TextBox 54">
+            <a:extLst>
+              <a:ext uri="{FF2B5EF4-FFF2-40B4-BE49-F238E27FC236}">
+                <a16:creationId xmlns:a16="http://schemas.microsoft.com/office/drawing/2014/main" id="{E9476CBD-FD8D-79A7-D14E-8CDFD127ADCA}"/>
+              </a:ext>
+            </a:extLst>
+          </p:cNvPr>
+          <p:cNvSpPr txBox="1"/>
+          <p:nvPr/>
+        </p:nvSpPr>
+        <p:spPr>
+          <a:xfrm>
+            <a:off x="7568333" y="5801124"/>
+            <a:ext cx="4193076" cy="646331"/>
+          </a:xfrm>
+          <a:prstGeom prst="rect">
+            <a:avLst/>
+          </a:prstGeom>
+          <a:noFill/>
+        </p:spPr>
+        <p:txBody>
+          <a:bodyPr wrap="square" rtlCol="0">
+            <a:spAutoFit/>
+          </a:bodyPr>
+          <a:lstStyle/>
+          <a:p>
+            <a:pPr algn="ctr"/>
+            <a:r>
+              <a:rPr lang="en-US" altLang="ko-KR" dirty="0"/>
+              <a:t>Model</a:t>
+            </a:r>
+            <a:r>
+              <a:rPr lang="ko-KR" altLang="en-US" dirty="0"/>
+              <a:t>이랑 같이 </a:t>
+            </a:r>
+            <a:r>
+              <a:rPr lang="en-US" altLang="ko-KR" dirty="0"/>
+              <a:t>write</a:t>
+            </a:r>
+          </a:p>
+          <a:p>
+            <a:pPr algn="ctr"/>
+            <a:r>
+              <a:rPr lang="en-US" altLang="ko-KR" dirty="0"/>
+              <a:t>Animation</a:t>
+            </a:r>
+            <a:r>
+              <a:rPr lang="ko-KR" altLang="en-US" dirty="0"/>
+              <a:t>은 별개로 </a:t>
+            </a:r>
+            <a:r>
+              <a:rPr lang="en-US" altLang="ko-KR" dirty="0"/>
+              <a:t>read</a:t>
+            </a:r>
+          </a:p>
+        </p:txBody>
+      </p:sp>
+      <p:grpSp>
+        <p:nvGrpSpPr>
+          <p:cNvPr id="2" name="그룹 1">
+            <a:extLst>
+              <a:ext uri="{FF2B5EF4-FFF2-40B4-BE49-F238E27FC236}">
+                <a16:creationId xmlns:a16="http://schemas.microsoft.com/office/drawing/2014/main" id="{01CAEF7A-546E-39AC-922A-817423CB2467}"/>
+              </a:ext>
+            </a:extLst>
+          </p:cNvPr>
+          <p:cNvGrpSpPr/>
+          <p:nvPr/>
+        </p:nvGrpSpPr>
+        <p:grpSpPr>
+          <a:xfrm>
+            <a:off x="198455" y="2967061"/>
+            <a:ext cx="7287805" cy="455976"/>
+            <a:chOff x="1057298" y="923087"/>
+            <a:chExt cx="9206317" cy="576774"/>
+          </a:xfrm>
+        </p:grpSpPr>
+        <p:sp>
+          <p:nvSpPr>
+            <p:cNvPr id="3" name="직사각형 2">
+              <a:extLst>
+                <a:ext uri="{FF2B5EF4-FFF2-40B4-BE49-F238E27FC236}">
+                  <a16:creationId xmlns:a16="http://schemas.microsoft.com/office/drawing/2014/main" id="{0FF63F4F-B808-6335-1934-BB6CC9B250E1}"/>
+                </a:ext>
+              </a:extLst>
+            </p:cNvPr>
+            <p:cNvSpPr/>
+            <p:nvPr/>
+          </p:nvSpPr>
+          <p:spPr>
+            <a:xfrm>
+              <a:off x="1057298" y="923087"/>
+              <a:ext cx="7518811" cy="576774"/>
+            </a:xfrm>
+            <a:prstGeom prst="rect">
+              <a:avLst/>
+            </a:prstGeom>
+            <a:solidFill>
+              <a:schemeClr val="accent1">
+                <a:lumMod val="20000"/>
+                <a:lumOff val="80000"/>
+              </a:schemeClr>
+            </a:solidFill>
+          </p:spPr>
+          <p:style>
+            <a:lnRef idx="2">
+              <a:schemeClr val="accent1">
+                <a:shade val="15000"/>
+              </a:schemeClr>
+            </a:lnRef>
+            <a:fillRef idx="1">
+              <a:schemeClr val="accent1"/>
+            </a:fillRef>
+            <a:effectRef idx="0">
+              <a:schemeClr val="accent1"/>
+            </a:effectRef>
+            <a:fontRef idx="minor">
+              <a:schemeClr val="lt1"/>
+            </a:fontRef>
+          </p:style>
+          <p:txBody>
+            <a:bodyPr rtlCol="0" anchor="ctr"/>
+            <a:lstStyle/>
+            <a:p>
+              <a:pPr algn="ctr"/>
+              <a:r>
+                <a:rPr lang="en-US" altLang="ko-KR" sz="1600" dirty="0">
+                  <a:solidFill>
+                    <a:schemeClr val="tx1"/>
+                  </a:solidFill>
+                </a:rPr>
+                <a:t>Data : Channel Count</a:t>
+              </a:r>
+              <a:endParaRPr lang="ko-KR" altLang="en-US" sz="1600" dirty="0">
+                <a:solidFill>
+                  <a:schemeClr val="tx1"/>
+                </a:solidFill>
+              </a:endParaRPr>
+            </a:p>
+          </p:txBody>
+        </p:sp>
+        <p:sp>
+          <p:nvSpPr>
+            <p:cNvPr id="5" name="직사각형 4">
+              <a:extLst>
+                <a:ext uri="{FF2B5EF4-FFF2-40B4-BE49-F238E27FC236}">
+                  <a16:creationId xmlns:a16="http://schemas.microsoft.com/office/drawing/2014/main" id="{287856E7-7DED-C4AD-92A1-3DC479FC314B}"/>
+                </a:ext>
+              </a:extLst>
+            </p:cNvPr>
+            <p:cNvSpPr/>
+            <p:nvPr/>
+          </p:nvSpPr>
+          <p:spPr>
+            <a:xfrm>
+              <a:off x="8576109" y="923087"/>
+              <a:ext cx="1687506" cy="576774"/>
+            </a:xfrm>
+            <a:prstGeom prst="rect">
+              <a:avLst/>
+            </a:prstGeom>
+            <a:solidFill>
+              <a:schemeClr val="accent1">
+                <a:lumMod val="20000"/>
+                <a:lumOff val="80000"/>
+              </a:schemeClr>
+            </a:solidFill>
+          </p:spPr>
+          <p:style>
+            <a:lnRef idx="2">
+              <a:schemeClr val="accent1">
+                <a:shade val="15000"/>
+              </a:schemeClr>
+            </a:lnRef>
+            <a:fillRef idx="1">
+              <a:schemeClr val="accent1"/>
+            </a:fillRef>
+            <a:effectRef idx="0">
+              <a:schemeClr val="accent1"/>
+            </a:effectRef>
+            <a:fontRef idx="minor">
+              <a:schemeClr val="lt1"/>
+            </a:fontRef>
+          </p:style>
+          <p:txBody>
+            <a:bodyPr rtlCol="0" anchor="ctr"/>
+            <a:lstStyle/>
+            <a:p>
+              <a:pPr algn="ctr"/>
+              <a:r>
+                <a:rPr lang="en-US" altLang="ko-KR" sz="1600" dirty="0">
+                  <a:solidFill>
+                    <a:schemeClr val="tx1"/>
+                  </a:solidFill>
+                </a:rPr>
+                <a:t>uint32_t</a:t>
+              </a:r>
+              <a:endParaRPr lang="ko-KR" altLang="en-US" sz="1600" dirty="0">
+                <a:solidFill>
+                  <a:schemeClr val="tx1"/>
+                </a:solidFill>
+              </a:endParaRPr>
+            </a:p>
+          </p:txBody>
+        </p:sp>
+      </p:grpSp>
+      <p:cxnSp>
+        <p:nvCxnSpPr>
+          <p:cNvPr id="6" name="직선 화살표 연결선 5">
+            <a:extLst>
+              <a:ext uri="{FF2B5EF4-FFF2-40B4-BE49-F238E27FC236}">
+                <a16:creationId xmlns:a16="http://schemas.microsoft.com/office/drawing/2014/main" id="{6F2CC8CB-2CD1-8C40-CECF-F991D11E8666}"/>
+              </a:ext>
+            </a:extLst>
+          </p:cNvPr>
+          <p:cNvCxnSpPr>
+            <a:cxnSpLocks/>
+          </p:cNvCxnSpPr>
+          <p:nvPr/>
+        </p:nvCxnSpPr>
+        <p:spPr>
+          <a:xfrm flipH="1">
+            <a:off x="3174435" y="3437760"/>
+            <a:ext cx="1" cy="384910"/>
+          </a:xfrm>
+          <a:prstGeom prst="straightConnector1">
+            <a:avLst/>
+          </a:prstGeom>
+          <a:ln>
+            <a:tailEnd type="triangle"/>
+          </a:ln>
+        </p:spPr>
+        <p:style>
+          <a:lnRef idx="2">
+            <a:schemeClr val="accent1"/>
+          </a:lnRef>
+          <a:fillRef idx="0">
+            <a:schemeClr val="accent1"/>
+          </a:fillRef>
+          <a:effectRef idx="1">
+            <a:schemeClr val="accent1"/>
+          </a:effectRef>
+          <a:fontRef idx="minor">
+            <a:schemeClr val="tx1"/>
+          </a:fontRef>
+        </p:style>
+      </p:cxnSp>
+      <p:sp>
+        <p:nvSpPr>
+          <p:cNvPr id="9" name="TextBox 8">
+            <a:extLst>
+              <a:ext uri="{FF2B5EF4-FFF2-40B4-BE49-F238E27FC236}">
+                <a16:creationId xmlns:a16="http://schemas.microsoft.com/office/drawing/2014/main" id="{664281E4-64E9-E795-D9DE-83E9FB3F4E11}"/>
+              </a:ext>
+            </a:extLst>
+          </p:cNvPr>
+          <p:cNvSpPr txBox="1"/>
+          <p:nvPr/>
+        </p:nvSpPr>
+        <p:spPr>
+          <a:xfrm>
+            <a:off x="3486823" y="3461752"/>
+            <a:ext cx="2992140" cy="338554"/>
+          </a:xfrm>
+          <a:prstGeom prst="rect">
+            <a:avLst/>
+          </a:prstGeom>
+          <a:noFill/>
+        </p:spPr>
+        <p:txBody>
+          <a:bodyPr wrap="square" rtlCol="0">
+            <a:spAutoFit/>
+          </a:bodyPr>
+          <a:lstStyle/>
+          <a:p>
+            <a:r>
+              <a:rPr lang="en-US" altLang="ko-KR" sz="1600" dirty="0"/>
+              <a:t>LOOP DATA : Channel Count</a:t>
+            </a:r>
+            <a:endParaRPr lang="ko-KR" altLang="en-US" sz="1600" dirty="0"/>
+          </a:p>
+        </p:txBody>
+      </p:sp>
+      <p:grpSp>
+        <p:nvGrpSpPr>
+          <p:cNvPr id="16" name="그룹 15">
+            <a:extLst>
+              <a:ext uri="{FF2B5EF4-FFF2-40B4-BE49-F238E27FC236}">
+                <a16:creationId xmlns:a16="http://schemas.microsoft.com/office/drawing/2014/main" id="{62FEDD5C-51A9-E838-3C89-17B38B088F33}"/>
+              </a:ext>
+            </a:extLst>
+          </p:cNvPr>
+          <p:cNvGrpSpPr/>
+          <p:nvPr/>
+        </p:nvGrpSpPr>
+        <p:grpSpPr>
+          <a:xfrm>
+            <a:off x="198455" y="3837393"/>
+            <a:ext cx="7287805" cy="455976"/>
+            <a:chOff x="1057298" y="923087"/>
+            <a:chExt cx="9206317" cy="576774"/>
+          </a:xfrm>
+        </p:grpSpPr>
+        <p:sp>
+          <p:nvSpPr>
+            <p:cNvPr id="18" name="직사각형 17">
+              <a:extLst>
+                <a:ext uri="{FF2B5EF4-FFF2-40B4-BE49-F238E27FC236}">
+                  <a16:creationId xmlns:a16="http://schemas.microsoft.com/office/drawing/2014/main" id="{214BAAA2-5445-11FE-98EE-7614AC8C122B}"/>
+                </a:ext>
+              </a:extLst>
+            </p:cNvPr>
+            <p:cNvSpPr/>
+            <p:nvPr/>
+          </p:nvSpPr>
+          <p:spPr>
+            <a:xfrm>
+              <a:off x="1057298" y="923087"/>
+              <a:ext cx="7518811" cy="576774"/>
+            </a:xfrm>
+            <a:prstGeom prst="rect">
+              <a:avLst/>
+            </a:prstGeom>
+            <a:solidFill>
+              <a:schemeClr val="accent1">
+                <a:lumMod val="20000"/>
+                <a:lumOff val="80000"/>
+              </a:schemeClr>
+            </a:solidFill>
+          </p:spPr>
+          <p:style>
+            <a:lnRef idx="2">
+              <a:schemeClr val="accent1">
+                <a:shade val="15000"/>
+              </a:schemeClr>
+            </a:lnRef>
+            <a:fillRef idx="1">
+              <a:schemeClr val="accent1"/>
+            </a:fillRef>
+            <a:effectRef idx="0">
+              <a:schemeClr val="accent1"/>
+            </a:effectRef>
+            <a:fontRef idx="minor">
+              <a:schemeClr val="lt1"/>
+            </a:fontRef>
+          </p:style>
+          <p:txBody>
+            <a:bodyPr rtlCol="0" anchor="ctr"/>
+            <a:lstStyle/>
+            <a:p>
+              <a:pPr algn="ctr"/>
+              <a:r>
+                <a:rPr lang="en-US" altLang="ko-KR" sz="1600" dirty="0">
+                  <a:solidFill>
+                    <a:schemeClr val="tx1"/>
+                  </a:solidFill>
+                </a:rPr>
+                <a:t>Data : Bone Index</a:t>
+              </a:r>
+              <a:endParaRPr lang="ko-KR" altLang="en-US" sz="1600" dirty="0">
+                <a:solidFill>
+                  <a:schemeClr val="tx1"/>
+                </a:solidFill>
+              </a:endParaRPr>
+            </a:p>
+          </p:txBody>
+        </p:sp>
+        <p:sp>
+          <p:nvSpPr>
+            <p:cNvPr id="29" name="직사각형 28">
+              <a:extLst>
+                <a:ext uri="{FF2B5EF4-FFF2-40B4-BE49-F238E27FC236}">
+                  <a16:creationId xmlns:a16="http://schemas.microsoft.com/office/drawing/2014/main" id="{6698A9ED-E02E-90B7-DD77-797EB227838E}"/>
+                </a:ext>
+              </a:extLst>
+            </p:cNvPr>
+            <p:cNvSpPr/>
+            <p:nvPr/>
+          </p:nvSpPr>
+          <p:spPr>
+            <a:xfrm>
+              <a:off x="8576109" y="923087"/>
+              <a:ext cx="1687506" cy="576774"/>
+            </a:xfrm>
+            <a:prstGeom prst="rect">
+              <a:avLst/>
+            </a:prstGeom>
+            <a:solidFill>
+              <a:schemeClr val="accent1">
+                <a:lumMod val="20000"/>
+                <a:lumOff val="80000"/>
+              </a:schemeClr>
+            </a:solidFill>
+          </p:spPr>
+          <p:style>
+            <a:lnRef idx="2">
+              <a:schemeClr val="accent1">
+                <a:shade val="15000"/>
+              </a:schemeClr>
+            </a:lnRef>
+            <a:fillRef idx="1">
+              <a:schemeClr val="accent1"/>
+            </a:fillRef>
+            <a:effectRef idx="0">
+              <a:schemeClr val="accent1"/>
+            </a:effectRef>
+            <a:fontRef idx="minor">
+              <a:schemeClr val="lt1"/>
+            </a:fontRef>
+          </p:style>
+          <p:txBody>
+            <a:bodyPr rtlCol="0" anchor="ctr"/>
+            <a:lstStyle/>
+            <a:p>
+              <a:pPr algn="ctr"/>
+              <a:r>
+                <a:rPr lang="en-US" altLang="ko-KR" sz="1600" dirty="0">
+                  <a:solidFill>
+                    <a:schemeClr val="tx1"/>
+                  </a:solidFill>
+                </a:rPr>
+                <a:t>int32_t</a:t>
+              </a:r>
+              <a:endParaRPr lang="ko-KR" altLang="en-US" sz="1600" dirty="0">
+                <a:solidFill>
+                  <a:schemeClr val="tx1"/>
+                </a:solidFill>
+              </a:endParaRPr>
+            </a:p>
+          </p:txBody>
+        </p:sp>
+      </p:grpSp>
+      <p:sp>
+        <p:nvSpPr>
+          <p:cNvPr id="31" name="TextBox 30">
+            <a:extLst>
+              <a:ext uri="{FF2B5EF4-FFF2-40B4-BE49-F238E27FC236}">
+                <a16:creationId xmlns:a16="http://schemas.microsoft.com/office/drawing/2014/main" id="{3E16BEB0-5067-A814-5CF6-30EB7A28694E}"/>
+              </a:ext>
+            </a:extLst>
+          </p:cNvPr>
+          <p:cNvSpPr txBox="1"/>
+          <p:nvPr/>
+        </p:nvSpPr>
+        <p:spPr>
+          <a:xfrm>
+            <a:off x="4118324" y="3968441"/>
+            <a:ext cx="1348825" cy="246221"/>
+          </a:xfrm>
+          <a:prstGeom prst="rect">
+            <a:avLst/>
+          </a:prstGeom>
+          <a:noFill/>
+        </p:spPr>
+        <p:txBody>
+          <a:bodyPr wrap="square" rtlCol="0">
+            <a:spAutoFit/>
+          </a:bodyPr>
+          <a:lstStyle/>
+          <a:p>
+            <a:r>
+              <a:rPr lang="ko-KR" altLang="en-US" sz="1000" dirty="0"/>
+              <a:t>해당하는 본 인덱스</a:t>
+            </a:r>
+          </a:p>
+        </p:txBody>
+      </p:sp>
+      <p:sp>
+        <p:nvSpPr>
+          <p:cNvPr id="34" name="TextBox 33">
+            <a:extLst>
+              <a:ext uri="{FF2B5EF4-FFF2-40B4-BE49-F238E27FC236}">
+                <a16:creationId xmlns:a16="http://schemas.microsoft.com/office/drawing/2014/main" id="{E8F0D1A1-187C-38F1-FE21-29E199E87DC5}"/>
+              </a:ext>
+            </a:extLst>
+          </p:cNvPr>
+          <p:cNvSpPr txBox="1"/>
+          <p:nvPr/>
+        </p:nvSpPr>
+        <p:spPr>
+          <a:xfrm>
+            <a:off x="444979" y="3478903"/>
+            <a:ext cx="2538851" cy="246221"/>
+          </a:xfrm>
+          <a:prstGeom prst="rect">
+            <a:avLst/>
+          </a:prstGeom>
+          <a:noFill/>
+        </p:spPr>
+        <p:txBody>
+          <a:bodyPr wrap="square" rtlCol="0">
+            <a:spAutoFit/>
+          </a:bodyPr>
+          <a:lstStyle/>
+          <a:p>
+            <a:r>
+              <a:rPr lang="ko-KR" altLang="en-US" sz="1000" dirty="0"/>
+              <a:t>채널은 뼈 하나 랑 동기화 된다고 생각</a:t>
+            </a:r>
+            <a:r>
+              <a:rPr lang="en-US" altLang="ko-KR" sz="1000" dirty="0"/>
+              <a:t>?</a:t>
+            </a:r>
+            <a:endParaRPr lang="ko-KR" altLang="en-US" sz="1000" dirty="0"/>
+          </a:p>
+        </p:txBody>
+      </p:sp>
+      <p:grpSp>
+        <p:nvGrpSpPr>
+          <p:cNvPr id="40" name="그룹 39">
+            <a:extLst>
+              <a:ext uri="{FF2B5EF4-FFF2-40B4-BE49-F238E27FC236}">
+                <a16:creationId xmlns:a16="http://schemas.microsoft.com/office/drawing/2014/main" id="{10A6C558-71C7-642C-AA56-C43C44EC2711}"/>
+              </a:ext>
+            </a:extLst>
+          </p:cNvPr>
+          <p:cNvGrpSpPr/>
+          <p:nvPr/>
+        </p:nvGrpSpPr>
+        <p:grpSpPr>
+          <a:xfrm>
+            <a:off x="198455" y="4293369"/>
+            <a:ext cx="7287805" cy="455976"/>
+            <a:chOff x="1057298" y="923087"/>
+            <a:chExt cx="9206317" cy="576774"/>
+          </a:xfrm>
+        </p:grpSpPr>
+        <p:sp>
+          <p:nvSpPr>
+            <p:cNvPr id="41" name="직사각형 40">
+              <a:extLst>
+                <a:ext uri="{FF2B5EF4-FFF2-40B4-BE49-F238E27FC236}">
+                  <a16:creationId xmlns:a16="http://schemas.microsoft.com/office/drawing/2014/main" id="{233E29B6-3BD2-133E-BA9B-4C896BA97466}"/>
+                </a:ext>
+              </a:extLst>
+            </p:cNvPr>
+            <p:cNvSpPr/>
+            <p:nvPr/>
+          </p:nvSpPr>
+          <p:spPr>
+            <a:xfrm>
+              <a:off x="1057298" y="923087"/>
+              <a:ext cx="7518811" cy="576774"/>
+            </a:xfrm>
+            <a:prstGeom prst="rect">
+              <a:avLst/>
+            </a:prstGeom>
+            <a:solidFill>
+              <a:schemeClr val="accent1">
+                <a:lumMod val="20000"/>
+                <a:lumOff val="80000"/>
+              </a:schemeClr>
+            </a:solidFill>
+          </p:spPr>
+          <p:style>
+            <a:lnRef idx="2">
+              <a:schemeClr val="accent1">
+                <a:shade val="15000"/>
+              </a:schemeClr>
+            </a:lnRef>
+            <a:fillRef idx="1">
+              <a:schemeClr val="accent1"/>
+            </a:fillRef>
+            <a:effectRef idx="0">
+              <a:schemeClr val="accent1"/>
+            </a:effectRef>
+            <a:fontRef idx="minor">
+              <a:schemeClr val="lt1"/>
+            </a:fontRef>
+          </p:style>
+          <p:txBody>
+            <a:bodyPr rtlCol="0" anchor="ctr"/>
+            <a:lstStyle/>
+            <a:p>
+              <a:pPr algn="ctr"/>
+              <a:r>
+                <a:rPr lang="en-US" altLang="ko-KR" sz="1600" dirty="0">
+                  <a:solidFill>
+                    <a:schemeClr val="tx1"/>
+                  </a:solidFill>
+                </a:rPr>
+                <a:t>Data : Key Frame Count</a:t>
+              </a:r>
+              <a:endParaRPr lang="ko-KR" altLang="en-US" sz="1600" dirty="0">
+                <a:solidFill>
+                  <a:schemeClr val="tx1"/>
+                </a:solidFill>
+              </a:endParaRPr>
+            </a:p>
+          </p:txBody>
+        </p:sp>
+        <p:sp>
+          <p:nvSpPr>
+            <p:cNvPr id="43" name="직사각형 42">
+              <a:extLst>
+                <a:ext uri="{FF2B5EF4-FFF2-40B4-BE49-F238E27FC236}">
+                  <a16:creationId xmlns:a16="http://schemas.microsoft.com/office/drawing/2014/main" id="{86862B2B-3C66-247E-269F-C0AB81D48F88}"/>
+                </a:ext>
+              </a:extLst>
+            </p:cNvPr>
+            <p:cNvSpPr/>
+            <p:nvPr/>
+          </p:nvSpPr>
+          <p:spPr>
+            <a:xfrm>
+              <a:off x="8576109" y="923087"/>
+              <a:ext cx="1687506" cy="576774"/>
+            </a:xfrm>
+            <a:prstGeom prst="rect">
+              <a:avLst/>
+            </a:prstGeom>
+            <a:solidFill>
+              <a:schemeClr val="accent1">
+                <a:lumMod val="20000"/>
+                <a:lumOff val="80000"/>
+              </a:schemeClr>
+            </a:solidFill>
+          </p:spPr>
+          <p:style>
+            <a:lnRef idx="2">
+              <a:schemeClr val="accent1">
+                <a:shade val="15000"/>
+              </a:schemeClr>
+            </a:lnRef>
+            <a:fillRef idx="1">
+              <a:schemeClr val="accent1"/>
+            </a:fillRef>
+            <a:effectRef idx="0">
+              <a:schemeClr val="accent1"/>
+            </a:effectRef>
+            <a:fontRef idx="minor">
+              <a:schemeClr val="lt1"/>
+            </a:fontRef>
+          </p:style>
+          <p:txBody>
+            <a:bodyPr rtlCol="0" anchor="ctr"/>
+            <a:lstStyle/>
+            <a:p>
+              <a:pPr algn="ctr"/>
+              <a:r>
+                <a:rPr lang="en-US" altLang="ko-KR" sz="1600" dirty="0">
+                  <a:solidFill>
+                    <a:schemeClr val="tx1"/>
+                  </a:solidFill>
+                </a:rPr>
+                <a:t>uint32_t</a:t>
+              </a:r>
+              <a:endParaRPr lang="ko-KR" altLang="en-US" sz="1600" dirty="0">
+                <a:solidFill>
+                  <a:schemeClr val="tx1"/>
+                </a:solidFill>
+              </a:endParaRPr>
+            </a:p>
+          </p:txBody>
+        </p:sp>
+      </p:grpSp>
+      <p:cxnSp>
+        <p:nvCxnSpPr>
+          <p:cNvPr id="45" name="직선 화살표 연결선 44">
+            <a:extLst>
+              <a:ext uri="{FF2B5EF4-FFF2-40B4-BE49-F238E27FC236}">
+                <a16:creationId xmlns:a16="http://schemas.microsoft.com/office/drawing/2014/main" id="{2401DFB4-EC72-664C-FED2-B8414EB5797E}"/>
+              </a:ext>
+            </a:extLst>
+          </p:cNvPr>
+          <p:cNvCxnSpPr>
+            <a:cxnSpLocks/>
+          </p:cNvCxnSpPr>
+          <p:nvPr/>
+        </p:nvCxnSpPr>
+        <p:spPr>
+          <a:xfrm flipH="1">
+            <a:off x="3174435" y="4726857"/>
+            <a:ext cx="1" cy="384910"/>
+          </a:xfrm>
+          <a:prstGeom prst="straightConnector1">
+            <a:avLst/>
+          </a:prstGeom>
+          <a:ln>
+            <a:tailEnd type="triangle"/>
+          </a:ln>
+        </p:spPr>
+        <p:style>
+          <a:lnRef idx="2">
+            <a:schemeClr val="accent1"/>
+          </a:lnRef>
+          <a:fillRef idx="0">
+            <a:schemeClr val="accent1"/>
+          </a:fillRef>
+          <a:effectRef idx="1">
+            <a:schemeClr val="accent1"/>
+          </a:effectRef>
+          <a:fontRef idx="minor">
+            <a:schemeClr val="tx1"/>
+          </a:fontRef>
+        </p:style>
+      </p:cxnSp>
+      <p:sp>
+        <p:nvSpPr>
+          <p:cNvPr id="46" name="TextBox 45">
+            <a:extLst>
+              <a:ext uri="{FF2B5EF4-FFF2-40B4-BE49-F238E27FC236}">
+                <a16:creationId xmlns:a16="http://schemas.microsoft.com/office/drawing/2014/main" id="{B4E2FC43-8C57-7688-4054-AA4C240CCADD}"/>
+              </a:ext>
+            </a:extLst>
+          </p:cNvPr>
+          <p:cNvSpPr txBox="1"/>
+          <p:nvPr/>
+        </p:nvSpPr>
+        <p:spPr>
+          <a:xfrm>
+            <a:off x="3486822" y="4750849"/>
+            <a:ext cx="3173859" cy="338554"/>
+          </a:xfrm>
+          <a:prstGeom prst="rect">
+            <a:avLst/>
+          </a:prstGeom>
+          <a:noFill/>
+        </p:spPr>
+        <p:txBody>
+          <a:bodyPr wrap="square" rtlCol="0">
+            <a:spAutoFit/>
+          </a:bodyPr>
+          <a:lstStyle/>
+          <a:p>
+            <a:r>
+              <a:rPr lang="en-US" altLang="ko-KR" sz="1600" dirty="0"/>
+              <a:t>LOOP DATA : Key Frame Count</a:t>
+            </a:r>
+            <a:endParaRPr lang="ko-KR" altLang="en-US" sz="1600" dirty="0"/>
+          </a:p>
+        </p:txBody>
+      </p:sp>
+      <p:grpSp>
+        <p:nvGrpSpPr>
+          <p:cNvPr id="47" name="그룹 46">
+            <a:extLst>
+              <a:ext uri="{FF2B5EF4-FFF2-40B4-BE49-F238E27FC236}">
+                <a16:creationId xmlns:a16="http://schemas.microsoft.com/office/drawing/2014/main" id="{79C87CB0-82BA-8C28-C5F1-B5D669E6AC65}"/>
+              </a:ext>
+            </a:extLst>
+          </p:cNvPr>
+          <p:cNvGrpSpPr/>
+          <p:nvPr/>
+        </p:nvGrpSpPr>
+        <p:grpSpPr>
+          <a:xfrm>
+            <a:off x="198455" y="5111767"/>
+            <a:ext cx="7287805" cy="455976"/>
+            <a:chOff x="1057298" y="923087"/>
+            <a:chExt cx="9206317" cy="576774"/>
+          </a:xfrm>
+        </p:grpSpPr>
+        <p:sp>
+          <p:nvSpPr>
+            <p:cNvPr id="48" name="직사각형 47">
+              <a:extLst>
+                <a:ext uri="{FF2B5EF4-FFF2-40B4-BE49-F238E27FC236}">
+                  <a16:creationId xmlns:a16="http://schemas.microsoft.com/office/drawing/2014/main" id="{80D464F8-B2E1-9D32-5624-5AC6C268B10E}"/>
+                </a:ext>
+              </a:extLst>
+            </p:cNvPr>
+            <p:cNvSpPr/>
+            <p:nvPr/>
+          </p:nvSpPr>
+          <p:spPr>
+            <a:xfrm>
+              <a:off x="1057298" y="923087"/>
+              <a:ext cx="7518812" cy="576774"/>
+            </a:xfrm>
+            <a:prstGeom prst="rect">
+              <a:avLst/>
+            </a:prstGeom>
+            <a:solidFill>
+              <a:schemeClr val="accent1">
+                <a:lumMod val="20000"/>
+                <a:lumOff val="80000"/>
+              </a:schemeClr>
+            </a:solidFill>
+          </p:spPr>
+          <p:style>
+            <a:lnRef idx="2">
+              <a:schemeClr val="accent1">
+                <a:shade val="15000"/>
+              </a:schemeClr>
+            </a:lnRef>
+            <a:fillRef idx="1">
+              <a:schemeClr val="accent1"/>
+            </a:fillRef>
+            <a:effectRef idx="0">
+              <a:schemeClr val="accent1"/>
+            </a:effectRef>
+            <a:fontRef idx="minor">
+              <a:schemeClr val="lt1"/>
+            </a:fontRef>
+          </p:style>
+          <p:txBody>
+            <a:bodyPr rtlCol="0" anchor="ctr"/>
+            <a:lstStyle/>
+            <a:p>
+              <a:pPr algn="ctr"/>
+              <a:r>
+                <a:rPr lang="en-US" altLang="ko-KR" sz="1600" dirty="0">
+                  <a:solidFill>
+                    <a:schemeClr val="tx1"/>
+                  </a:solidFill>
+                </a:rPr>
+                <a:t>Data : Scale</a:t>
+              </a:r>
+              <a:endParaRPr lang="ko-KR" altLang="en-US" sz="1600" dirty="0">
+                <a:solidFill>
+                  <a:schemeClr val="tx1"/>
+                </a:solidFill>
+              </a:endParaRPr>
+            </a:p>
+          </p:txBody>
+        </p:sp>
+        <p:sp>
+          <p:nvSpPr>
+            <p:cNvPr id="49" name="직사각형 48">
+              <a:extLst>
+                <a:ext uri="{FF2B5EF4-FFF2-40B4-BE49-F238E27FC236}">
+                  <a16:creationId xmlns:a16="http://schemas.microsoft.com/office/drawing/2014/main" id="{031B1CED-3EEA-4C24-BC88-CAD3DF57ECD9}"/>
+                </a:ext>
+              </a:extLst>
+            </p:cNvPr>
+            <p:cNvSpPr/>
+            <p:nvPr/>
+          </p:nvSpPr>
+          <p:spPr>
+            <a:xfrm>
+              <a:off x="8576109" y="923087"/>
+              <a:ext cx="1687506" cy="576774"/>
+            </a:xfrm>
+            <a:prstGeom prst="rect">
+              <a:avLst/>
+            </a:prstGeom>
+            <a:solidFill>
+              <a:schemeClr val="accent1">
+                <a:lumMod val="20000"/>
+                <a:lumOff val="80000"/>
+              </a:schemeClr>
+            </a:solidFill>
+          </p:spPr>
+          <p:style>
+            <a:lnRef idx="2">
+              <a:schemeClr val="accent1">
+                <a:shade val="15000"/>
+              </a:schemeClr>
+            </a:lnRef>
+            <a:fillRef idx="1">
+              <a:schemeClr val="accent1"/>
+            </a:fillRef>
+            <a:effectRef idx="0">
+              <a:schemeClr val="accent1"/>
+            </a:effectRef>
+            <a:fontRef idx="minor">
+              <a:schemeClr val="lt1"/>
+            </a:fontRef>
+          </p:style>
+          <p:txBody>
+            <a:bodyPr rtlCol="0" anchor="ctr"/>
+            <a:lstStyle/>
+            <a:p>
+              <a:pPr algn="ctr"/>
+              <a:r>
+                <a:rPr lang="en-US" altLang="ko-KR" sz="1600" dirty="0">
+                  <a:solidFill>
+                    <a:schemeClr val="tx1"/>
+                  </a:solidFill>
+                </a:rPr>
+                <a:t>XMFLOAT3</a:t>
+              </a:r>
+              <a:endParaRPr lang="ko-KR" altLang="en-US" sz="1600" dirty="0">
+                <a:solidFill>
+                  <a:schemeClr val="tx1"/>
+                </a:solidFill>
+              </a:endParaRPr>
+            </a:p>
+          </p:txBody>
+        </p:sp>
+      </p:grpSp>
+      <p:pic>
+        <p:nvPicPr>
+          <p:cNvPr id="57" name="그림 56">
+            <a:extLst>
+              <a:ext uri="{FF2B5EF4-FFF2-40B4-BE49-F238E27FC236}">
+                <a16:creationId xmlns:a16="http://schemas.microsoft.com/office/drawing/2014/main" id="{E4673D57-FA0C-CF0F-47DB-6A68BF390CA7}"/>
+              </a:ext>
+            </a:extLst>
+          </p:cNvPr>
+          <p:cNvPicPr>
+            <a:picLocks noChangeAspect="1"/>
+          </p:cNvPicPr>
+          <p:nvPr/>
+        </p:nvPicPr>
+        <p:blipFill>
+          <a:blip r:embed="rId2"/>
+          <a:stretch>
+            <a:fillRect/>
+          </a:stretch>
+        </p:blipFill>
+        <p:spPr>
+          <a:xfrm>
+            <a:off x="7922152" y="512684"/>
+            <a:ext cx="3667637" cy="1733792"/>
+          </a:xfrm>
+          <a:prstGeom prst="rect">
+            <a:avLst/>
+          </a:prstGeom>
+        </p:spPr>
+      </p:pic>
+      <p:pic>
+        <p:nvPicPr>
+          <p:cNvPr id="71" name="그림 70">
+            <a:extLst>
+              <a:ext uri="{FF2B5EF4-FFF2-40B4-BE49-F238E27FC236}">
+                <a16:creationId xmlns:a16="http://schemas.microsoft.com/office/drawing/2014/main" id="{F57CBFE5-A351-478B-4AA5-35264E7E41B1}"/>
+              </a:ext>
+            </a:extLst>
+          </p:cNvPr>
+          <p:cNvPicPr>
+            <a:picLocks noChangeAspect="1"/>
+          </p:cNvPicPr>
+          <p:nvPr/>
+        </p:nvPicPr>
+        <p:blipFill>
+          <a:blip r:embed="rId3"/>
+          <a:stretch>
+            <a:fillRect/>
+          </a:stretch>
+        </p:blipFill>
+        <p:spPr>
+          <a:xfrm>
+            <a:off x="7852020" y="2591733"/>
+            <a:ext cx="4021291" cy="2753415"/>
+          </a:xfrm>
+          <a:prstGeom prst="rect">
+            <a:avLst/>
+          </a:prstGeom>
+        </p:spPr>
+      </p:pic>
+      <p:grpSp>
+        <p:nvGrpSpPr>
+          <p:cNvPr id="72" name="그룹 71">
+            <a:extLst>
+              <a:ext uri="{FF2B5EF4-FFF2-40B4-BE49-F238E27FC236}">
+                <a16:creationId xmlns:a16="http://schemas.microsoft.com/office/drawing/2014/main" id="{F83D61F3-5EAB-DCB3-7932-9C6F8B9EE375}"/>
+              </a:ext>
+            </a:extLst>
+          </p:cNvPr>
+          <p:cNvGrpSpPr/>
+          <p:nvPr/>
+        </p:nvGrpSpPr>
+        <p:grpSpPr>
+          <a:xfrm>
+            <a:off x="201663" y="5545255"/>
+            <a:ext cx="7287805" cy="455976"/>
+            <a:chOff x="1057298" y="923087"/>
+            <a:chExt cx="9206317" cy="576774"/>
+          </a:xfrm>
+        </p:grpSpPr>
+        <p:sp>
+          <p:nvSpPr>
+            <p:cNvPr id="73" name="직사각형 72">
+              <a:extLst>
+                <a:ext uri="{FF2B5EF4-FFF2-40B4-BE49-F238E27FC236}">
+                  <a16:creationId xmlns:a16="http://schemas.microsoft.com/office/drawing/2014/main" id="{96283AD8-1C6A-99E8-BB2D-CFDA659D6C6E}"/>
+                </a:ext>
+              </a:extLst>
+            </p:cNvPr>
+            <p:cNvSpPr/>
+            <p:nvPr/>
+          </p:nvSpPr>
+          <p:spPr>
+            <a:xfrm>
+              <a:off x="1057298" y="923087"/>
+              <a:ext cx="7518812" cy="576774"/>
+            </a:xfrm>
+            <a:prstGeom prst="rect">
+              <a:avLst/>
+            </a:prstGeom>
+            <a:solidFill>
+              <a:schemeClr val="accent1">
+                <a:lumMod val="20000"/>
+                <a:lumOff val="80000"/>
+              </a:schemeClr>
+            </a:solidFill>
+          </p:spPr>
+          <p:style>
+            <a:lnRef idx="2">
+              <a:schemeClr val="accent1">
+                <a:shade val="15000"/>
+              </a:schemeClr>
+            </a:lnRef>
+            <a:fillRef idx="1">
+              <a:schemeClr val="accent1"/>
+            </a:fillRef>
+            <a:effectRef idx="0">
+              <a:schemeClr val="accent1"/>
+            </a:effectRef>
+            <a:fontRef idx="minor">
+              <a:schemeClr val="lt1"/>
+            </a:fontRef>
+          </p:style>
+          <p:txBody>
+            <a:bodyPr rtlCol="0" anchor="ctr"/>
+            <a:lstStyle/>
+            <a:p>
+              <a:pPr algn="ctr"/>
+              <a:r>
+                <a:rPr lang="en-US" altLang="ko-KR" sz="1600" dirty="0">
+                  <a:solidFill>
+                    <a:schemeClr val="tx1"/>
+                  </a:solidFill>
+                </a:rPr>
+                <a:t>Data : Rotation</a:t>
+              </a:r>
+              <a:endParaRPr lang="ko-KR" altLang="en-US" sz="1600" dirty="0">
+                <a:solidFill>
+                  <a:schemeClr val="tx1"/>
+                </a:solidFill>
+              </a:endParaRPr>
+            </a:p>
+          </p:txBody>
+        </p:sp>
+        <p:sp>
+          <p:nvSpPr>
+            <p:cNvPr id="74" name="직사각형 73">
+              <a:extLst>
+                <a:ext uri="{FF2B5EF4-FFF2-40B4-BE49-F238E27FC236}">
+                  <a16:creationId xmlns:a16="http://schemas.microsoft.com/office/drawing/2014/main" id="{5BF19090-8439-D6E9-E9FE-14834398AC49}"/>
+                </a:ext>
+              </a:extLst>
+            </p:cNvPr>
+            <p:cNvSpPr/>
+            <p:nvPr/>
+          </p:nvSpPr>
+          <p:spPr>
+            <a:xfrm>
+              <a:off x="8576109" y="923087"/>
+              <a:ext cx="1687506" cy="576774"/>
+            </a:xfrm>
+            <a:prstGeom prst="rect">
+              <a:avLst/>
+            </a:prstGeom>
+            <a:solidFill>
+              <a:schemeClr val="accent1">
+                <a:lumMod val="20000"/>
+                <a:lumOff val="80000"/>
+              </a:schemeClr>
+            </a:solidFill>
+          </p:spPr>
+          <p:style>
+            <a:lnRef idx="2">
+              <a:schemeClr val="accent1">
+                <a:shade val="15000"/>
+              </a:schemeClr>
+            </a:lnRef>
+            <a:fillRef idx="1">
+              <a:schemeClr val="accent1"/>
+            </a:fillRef>
+            <a:effectRef idx="0">
+              <a:schemeClr val="accent1"/>
+            </a:effectRef>
+            <a:fontRef idx="minor">
+              <a:schemeClr val="lt1"/>
+            </a:fontRef>
+          </p:style>
+          <p:txBody>
+            <a:bodyPr rtlCol="0" anchor="ctr"/>
+            <a:lstStyle/>
+            <a:p>
+              <a:pPr algn="ctr"/>
+              <a:r>
+                <a:rPr lang="en-US" altLang="ko-KR" sz="1600" dirty="0">
+                  <a:solidFill>
+                    <a:schemeClr val="tx1"/>
+                  </a:solidFill>
+                </a:rPr>
+                <a:t>XMFLOAT4</a:t>
+              </a:r>
+              <a:endParaRPr lang="ko-KR" altLang="en-US" sz="1600" dirty="0">
+                <a:solidFill>
+                  <a:schemeClr val="tx1"/>
+                </a:solidFill>
+              </a:endParaRPr>
+            </a:p>
+          </p:txBody>
+        </p:sp>
+      </p:grpSp>
+      <p:grpSp>
+        <p:nvGrpSpPr>
+          <p:cNvPr id="75" name="그룹 74">
+            <a:extLst>
+              <a:ext uri="{FF2B5EF4-FFF2-40B4-BE49-F238E27FC236}">
+                <a16:creationId xmlns:a16="http://schemas.microsoft.com/office/drawing/2014/main" id="{4DDA1C26-2BE0-17F8-BCEB-1B7AAEFF056A}"/>
+              </a:ext>
+            </a:extLst>
+          </p:cNvPr>
+          <p:cNvGrpSpPr/>
+          <p:nvPr/>
+        </p:nvGrpSpPr>
+        <p:grpSpPr>
+          <a:xfrm>
+            <a:off x="201663" y="5986453"/>
+            <a:ext cx="7287805" cy="455976"/>
+            <a:chOff x="1057298" y="923087"/>
+            <a:chExt cx="9206317" cy="576774"/>
+          </a:xfrm>
+        </p:grpSpPr>
+        <p:sp>
+          <p:nvSpPr>
+            <p:cNvPr id="76" name="직사각형 75">
+              <a:extLst>
+                <a:ext uri="{FF2B5EF4-FFF2-40B4-BE49-F238E27FC236}">
+                  <a16:creationId xmlns:a16="http://schemas.microsoft.com/office/drawing/2014/main" id="{1E77441B-6771-2974-0893-A827220B2991}"/>
+                </a:ext>
+              </a:extLst>
+            </p:cNvPr>
+            <p:cNvSpPr/>
+            <p:nvPr/>
+          </p:nvSpPr>
+          <p:spPr>
+            <a:xfrm>
+              <a:off x="1057298" y="923087"/>
+              <a:ext cx="7518812" cy="576774"/>
+            </a:xfrm>
+            <a:prstGeom prst="rect">
+              <a:avLst/>
+            </a:prstGeom>
+            <a:solidFill>
+              <a:schemeClr val="accent1">
+                <a:lumMod val="20000"/>
+                <a:lumOff val="80000"/>
+              </a:schemeClr>
+            </a:solidFill>
+          </p:spPr>
+          <p:style>
+            <a:lnRef idx="2">
+              <a:schemeClr val="accent1">
+                <a:shade val="15000"/>
+              </a:schemeClr>
+            </a:lnRef>
+            <a:fillRef idx="1">
+              <a:schemeClr val="accent1"/>
+            </a:fillRef>
+            <a:effectRef idx="0">
+              <a:schemeClr val="accent1"/>
+            </a:effectRef>
+            <a:fontRef idx="minor">
+              <a:schemeClr val="lt1"/>
+            </a:fontRef>
+          </p:style>
+          <p:txBody>
+            <a:bodyPr rtlCol="0" anchor="ctr"/>
+            <a:lstStyle/>
+            <a:p>
+              <a:pPr algn="ctr"/>
+              <a:r>
+                <a:rPr lang="en-US" altLang="ko-KR" sz="1600" dirty="0">
+                  <a:solidFill>
+                    <a:schemeClr val="tx1"/>
+                  </a:solidFill>
+                </a:rPr>
+                <a:t>Data : Translation</a:t>
+              </a:r>
+              <a:endParaRPr lang="ko-KR" altLang="en-US" sz="1600" dirty="0">
+                <a:solidFill>
+                  <a:schemeClr val="tx1"/>
+                </a:solidFill>
+              </a:endParaRPr>
+            </a:p>
+          </p:txBody>
+        </p:sp>
+        <p:sp>
+          <p:nvSpPr>
+            <p:cNvPr id="77" name="직사각형 76">
+              <a:extLst>
+                <a:ext uri="{FF2B5EF4-FFF2-40B4-BE49-F238E27FC236}">
+                  <a16:creationId xmlns:a16="http://schemas.microsoft.com/office/drawing/2014/main" id="{82D9BF9A-42F5-C396-869C-B021B30C27B6}"/>
+                </a:ext>
+              </a:extLst>
+            </p:cNvPr>
+            <p:cNvSpPr/>
+            <p:nvPr/>
+          </p:nvSpPr>
+          <p:spPr>
+            <a:xfrm>
+              <a:off x="8576109" y="923087"/>
+              <a:ext cx="1687506" cy="576774"/>
+            </a:xfrm>
+            <a:prstGeom prst="rect">
+              <a:avLst/>
+            </a:prstGeom>
+            <a:solidFill>
+              <a:schemeClr val="accent1">
+                <a:lumMod val="20000"/>
+                <a:lumOff val="80000"/>
+              </a:schemeClr>
+            </a:solidFill>
+          </p:spPr>
+          <p:style>
+            <a:lnRef idx="2">
+              <a:schemeClr val="accent1">
+                <a:shade val="15000"/>
+              </a:schemeClr>
+            </a:lnRef>
+            <a:fillRef idx="1">
+              <a:schemeClr val="accent1"/>
+            </a:fillRef>
+            <a:effectRef idx="0">
+              <a:schemeClr val="accent1"/>
+            </a:effectRef>
+            <a:fontRef idx="minor">
+              <a:schemeClr val="lt1"/>
+            </a:fontRef>
+          </p:style>
+          <p:txBody>
+            <a:bodyPr rtlCol="0" anchor="ctr"/>
+            <a:lstStyle/>
+            <a:p>
+              <a:pPr algn="ctr"/>
+              <a:r>
+                <a:rPr lang="en-US" altLang="ko-KR" sz="1600" dirty="0">
+                  <a:solidFill>
+                    <a:schemeClr val="tx1"/>
+                  </a:solidFill>
+                </a:rPr>
+                <a:t>XMFLOAT3</a:t>
+              </a:r>
+              <a:endParaRPr lang="ko-KR" altLang="en-US" sz="1600" dirty="0">
+                <a:solidFill>
+                  <a:schemeClr val="tx1"/>
+                </a:solidFill>
+              </a:endParaRPr>
+            </a:p>
+          </p:txBody>
+        </p:sp>
+      </p:grpSp>
+      <p:grpSp>
+        <p:nvGrpSpPr>
+          <p:cNvPr id="78" name="그룹 77">
+            <a:extLst>
+              <a:ext uri="{FF2B5EF4-FFF2-40B4-BE49-F238E27FC236}">
+                <a16:creationId xmlns:a16="http://schemas.microsoft.com/office/drawing/2014/main" id="{7ED9D103-C5F6-9ACA-147E-69DA826A6095}"/>
+              </a:ext>
+            </a:extLst>
+          </p:cNvPr>
+          <p:cNvGrpSpPr/>
+          <p:nvPr/>
+        </p:nvGrpSpPr>
+        <p:grpSpPr>
+          <a:xfrm>
+            <a:off x="198455" y="6427651"/>
+            <a:ext cx="7287805" cy="455976"/>
+            <a:chOff x="1057298" y="923087"/>
+            <a:chExt cx="9206317" cy="576774"/>
+          </a:xfrm>
+        </p:grpSpPr>
+        <p:sp>
+          <p:nvSpPr>
+            <p:cNvPr id="79" name="직사각형 78">
+              <a:extLst>
+                <a:ext uri="{FF2B5EF4-FFF2-40B4-BE49-F238E27FC236}">
+                  <a16:creationId xmlns:a16="http://schemas.microsoft.com/office/drawing/2014/main" id="{55FB8B32-C3AA-0E5D-A295-A6F2B0919FBD}"/>
+                </a:ext>
+              </a:extLst>
+            </p:cNvPr>
+            <p:cNvSpPr/>
+            <p:nvPr/>
+          </p:nvSpPr>
+          <p:spPr>
+            <a:xfrm>
+              <a:off x="1057298" y="923087"/>
+              <a:ext cx="7518812" cy="576774"/>
+            </a:xfrm>
+            <a:prstGeom prst="rect">
+              <a:avLst/>
+            </a:prstGeom>
+            <a:solidFill>
+              <a:schemeClr val="accent1">
+                <a:lumMod val="20000"/>
+                <a:lumOff val="80000"/>
+              </a:schemeClr>
+            </a:solidFill>
+          </p:spPr>
+          <p:style>
+            <a:lnRef idx="2">
+              <a:schemeClr val="accent1">
+                <a:shade val="15000"/>
+              </a:schemeClr>
+            </a:lnRef>
+            <a:fillRef idx="1">
+              <a:schemeClr val="accent1"/>
+            </a:fillRef>
+            <a:effectRef idx="0">
+              <a:schemeClr val="accent1"/>
+            </a:effectRef>
+            <a:fontRef idx="minor">
+              <a:schemeClr val="lt1"/>
+            </a:fontRef>
+          </p:style>
+          <p:txBody>
+            <a:bodyPr rtlCol="0" anchor="ctr"/>
+            <a:lstStyle/>
+            <a:p>
+              <a:pPr algn="ctr"/>
+              <a:r>
+                <a:rPr lang="en-US" altLang="ko-KR" sz="1600" dirty="0">
+                  <a:solidFill>
+                    <a:schemeClr val="tx1"/>
+                  </a:solidFill>
+                </a:rPr>
+                <a:t>Data : </a:t>
+              </a:r>
+              <a:r>
+                <a:rPr lang="en-US" altLang="ko-KR" sz="1600" dirty="0" err="1">
+                  <a:solidFill>
+                    <a:schemeClr val="tx1"/>
+                  </a:solidFill>
+                </a:rPr>
+                <a:t>TrackPosition</a:t>
+              </a:r>
+              <a:endParaRPr lang="ko-KR" altLang="en-US" sz="1600" dirty="0">
+                <a:solidFill>
+                  <a:schemeClr val="tx1"/>
+                </a:solidFill>
+              </a:endParaRPr>
+            </a:p>
+          </p:txBody>
+        </p:sp>
+        <p:sp>
+          <p:nvSpPr>
+            <p:cNvPr id="80" name="직사각형 79">
+              <a:extLst>
+                <a:ext uri="{FF2B5EF4-FFF2-40B4-BE49-F238E27FC236}">
+                  <a16:creationId xmlns:a16="http://schemas.microsoft.com/office/drawing/2014/main" id="{E373BE2E-8EB2-3FEE-3239-BDC09E0B832E}"/>
+                </a:ext>
+              </a:extLst>
+            </p:cNvPr>
+            <p:cNvSpPr/>
+            <p:nvPr/>
+          </p:nvSpPr>
+          <p:spPr>
+            <a:xfrm>
+              <a:off x="8576109" y="923087"/>
+              <a:ext cx="1687506" cy="576774"/>
+            </a:xfrm>
+            <a:prstGeom prst="rect">
+              <a:avLst/>
+            </a:prstGeom>
+            <a:solidFill>
+              <a:schemeClr val="accent1">
+                <a:lumMod val="20000"/>
+                <a:lumOff val="80000"/>
+              </a:schemeClr>
+            </a:solidFill>
+          </p:spPr>
+          <p:style>
+            <a:lnRef idx="2">
+              <a:schemeClr val="accent1">
+                <a:shade val="15000"/>
+              </a:schemeClr>
+            </a:lnRef>
+            <a:fillRef idx="1">
+              <a:schemeClr val="accent1"/>
+            </a:fillRef>
+            <a:effectRef idx="0">
+              <a:schemeClr val="accent1"/>
+            </a:effectRef>
+            <a:fontRef idx="minor">
+              <a:schemeClr val="lt1"/>
+            </a:fontRef>
+          </p:style>
+          <p:txBody>
+            <a:bodyPr rtlCol="0" anchor="ctr"/>
+            <a:lstStyle/>
+            <a:p>
+              <a:pPr algn="ctr"/>
+              <a:r>
+                <a:rPr lang="en-US" altLang="ko-KR" sz="1600" dirty="0">
+                  <a:solidFill>
+                    <a:schemeClr val="tx1"/>
+                  </a:solidFill>
+                </a:rPr>
+                <a:t>float</a:t>
+              </a:r>
+              <a:endParaRPr lang="ko-KR" altLang="en-US" sz="1600" dirty="0">
+                <a:solidFill>
+                  <a:schemeClr val="tx1"/>
+                </a:solidFill>
+              </a:endParaRPr>
+            </a:p>
+          </p:txBody>
+        </p:sp>
+      </p:grpSp>
+    </p:spTree>
+    <p:extLst>
+      <p:ext uri="{BB962C8B-B14F-4D97-AF65-F5344CB8AC3E}">
+        <p14:creationId xmlns:p14="http://schemas.microsoft.com/office/powerpoint/2010/main" val="1968512673"/>
+      </p:ext>
+    </p:extLst>
+  </p:cSld>
+  <p:clrMapOvr>
+    <a:masterClrMapping/>
+  </p:clrMapOvr>
+</p:sld>
+</file>
+
 <file path=ppt/theme/theme1.xml><?xml version="1.0" encoding="utf-8"?>
 <a:theme xmlns:a="http://schemas.openxmlformats.org/drawingml/2006/main" name="Office 테마">
   <a:themeElements>

</xml_diff>